<commit_message>
Enhance agent communication guidelines and update statistics
- Added new rule for shorthand communication with users in `.cursor/rules/shorthand-with-user.mdc`, emphasizing the importance of spelling out terms before using shorthands.
- Updated `AGENTS.md` to include the new shorthand rule, improving clarity in agent-user interactions.
- Revised `statistics.json` to reflect updated user and agent message counts, ensuring accurate tracking of project activity.

These changes improve the communication framework for agents, fostering clearer interactions and enhancing overall project documentation.
</commit_message>
<xml_diff>
--- a/3-Master_Plan/re_entry/HEROs_and_PASSes/slides/CHAR_PD20_HAND.pptx
+++ b/3-Master_Plan/re_entry/HEROs_and_PASSes/slides/CHAR_PD20_HAND.pptx
@@ -3325,86 +3325,6 @@
           <a:chExt cx="0" cy="0"/>
         </a:xfrm>
       </p:grpSpPr>
-      <p:sp>
-        <p:nvSpPr>
-          <p:cNvPr id="2" name="Title 1">
-            <a:extLst>
-              <a:ext uri="{FF2B5EF4-FFF2-40B4-BE49-F238E27FC236}">
-                <a16:creationId xmlns:a16="http://schemas.microsoft.com/office/drawing/2014/main" id="{02E51B03-E884-98A3-7F67-D94217D4CFAF}"/>
-              </a:ext>
-            </a:extLst>
-          </p:cNvPr>
-          <p:cNvSpPr>
-            <a:spLocks noGrp="1"/>
-          </p:cNvSpPr>
-          <p:nvPr>
-            <p:ph type="ctrTitle"/>
-          </p:nvPr>
-        </p:nvSpPr>
-        <p:spPr/>
-        <p:txBody>
-          <a:bodyPr/>
-          <a:lstStyle/>
-          <a:p>
-            <a:endParaRPr lang="en-US"/>
-          </a:p>
-        </p:txBody>
-      </p:sp>
-      <p:sp>
-        <p:nvSpPr>
-          <p:cNvPr id="3" name="Subtitle 2">
-            <a:extLst>
-              <a:ext uri="{FF2B5EF4-FFF2-40B4-BE49-F238E27FC236}">
-                <a16:creationId xmlns:a16="http://schemas.microsoft.com/office/drawing/2014/main" id="{7A2D061F-19C2-9DAC-6603-536C44D4097F}"/>
-              </a:ext>
-            </a:extLst>
-          </p:cNvPr>
-          <p:cNvSpPr>
-            <a:spLocks noGrp="1"/>
-          </p:cNvSpPr>
-          <p:nvPr>
-            <p:ph type="subTitle" idx="1"/>
-          </p:nvPr>
-        </p:nvSpPr>
-        <p:spPr/>
-        <p:txBody>
-          <a:bodyPr/>
-          <a:lstStyle/>
-          <a:p>
-            <a:endParaRPr lang="en-US"/>
-          </a:p>
-        </p:txBody>
-      </p:sp>
-    </p:spTree>
-    <p:extLst>
-      <p:ext uri="{BB962C8B-B14F-4D97-AF65-F5344CB8AC3E}">
-        <p14:creationId xmlns:p14="http://schemas.microsoft.com/office/powerpoint/2010/main" val="3958339828"/>
-      </p:ext>
-    </p:extLst>
-  </p:cSld>
-  <p:clrMapOvr>
-    <a:masterClrMapping/>
-  </p:clrMapOvr>
-</p:sld>
-</file>
-
-<file path=ppt/slides/slide2.xml><?xml version="1.0" encoding="utf-8"?>
-<p:sld xmlns:a="http://schemas.openxmlformats.org/drawingml/2006/main" xmlns:r="http://schemas.openxmlformats.org/officeDocument/2006/relationships" xmlns:p="http://schemas.openxmlformats.org/presentationml/2006/main">
-  <p:cSld>
-    <p:spTree>
-      <p:nvGrpSpPr>
-        <p:cNvPr id="1" name=""/>
-        <p:cNvGrpSpPr/>
-        <p:nvPr/>
-      </p:nvGrpSpPr>
-      <p:grpSpPr>
-        <a:xfrm>
-          <a:off x="0" y="0"/>
-          <a:ext cx="0" cy="0"/>
-          <a:chOff x="0" y="0"/>
-          <a:chExt cx="0" cy="0"/>
-        </a:xfrm>
-      </p:grpSpPr>
       <mc:AlternateContent xmlns:mc="http://schemas.openxmlformats.org/markup-compatibility/2006">
         <mc:Choice xmlns:a14="http://schemas.microsoft.com/office/drawing/2010/main" Requires="a14">
           <p:sp>
@@ -4261,7 +4181,7 @@
 </p:sld>
 </file>
 
-<file path=ppt/slides/slide3.xml><?xml version="1.0" encoding="utf-8"?>
+<file path=ppt/slides/slide2.xml><?xml version="1.0" encoding="utf-8"?>
 <p:sld xmlns:a="http://schemas.openxmlformats.org/drawingml/2006/main" xmlns:r="http://schemas.openxmlformats.org/officeDocument/2006/relationships" xmlns:p="http://schemas.openxmlformats.org/presentationml/2006/main">
   <p:cSld>
     <p:spTree>
@@ -4569,7 +4489,7 @@
           <p:nvPr/>
         </p:nvPicPr>
         <p:blipFill>
-          <a:blip r:embed="rId4"/>
+          <a:blip/>
           <a:stretch>
             <a:fillRect/>
           </a:stretch>
@@ -4872,7 +4792,7 @@
                 <a:avLst/>
               </a:prstGeom>
               <a:blipFill>
-                <a:blip r:embed="rId5"/>
+                <a:blip r:embed="rId4"/>
                 <a:stretch>
                   <a:fillRect b="-1504"/>
                 </a:stretch>
@@ -5000,7 +4920,648 @@
                 <a:avLst/>
               </a:prstGeom>
               <a:blipFill>
-                <a:blip r:embed="rId6"/>
+                <a:blip r:embed="rId5"/>
+                <a:stretch>
+                  <a:fillRect b="-13636"/>
+                </a:stretch>
+              </a:blipFill>
+            </p:spPr>
+            <p:txBody>
+              <a:bodyPr/>
+              <a:lstStyle/>
+              <a:p>
+                <a:r>
+                  <a:rPr lang="en-US">
+                    <a:noFill/>
+                  </a:rPr>
+                  <a:t> </a:t>
+                </a:r>
+              </a:p>
+            </p:txBody>
+          </p:sp>
+        </mc:Fallback>
+      </mc:AlternateContent>
+    </p:spTree>
+  </p:cSld>
+  <p:clrMapOvr>
+    <a:masterClrMapping/>
+  </p:clrMapOvr>
+</p:sld>
+</file>
+
+<file path=ppt/slides/slide3.xml><?xml version="1.0" encoding="utf-8"?>
+<p:sld xmlns:a="http://schemas.openxmlformats.org/drawingml/2006/main" xmlns:r="http://schemas.openxmlformats.org/officeDocument/2006/relationships" xmlns:p="http://schemas.openxmlformats.org/presentationml/2006/main">
+  <p:cSld>
+    <p:spTree>
+      <p:nvGrpSpPr>
+        <p:cNvPr id="1" name=""/>
+        <p:cNvGrpSpPr/>
+        <p:nvPr/>
+      </p:nvGrpSpPr>
+      <p:grpSpPr>
+        <a:xfrm>
+          <a:off x="0" y="0"/>
+          <a:ext cx="0" cy="0"/>
+          <a:chOff x="0" y="0"/>
+          <a:chExt cx="0" cy="0"/>
+        </a:xfrm>
+      </p:grpSpPr>
+      <p:sp>
+        <p:nvSpPr>
+          <p:cNvPr id="2" name="TextBox 1"/>
+          <p:cNvSpPr txBox="1"/>
+          <p:nvPr/>
+        </p:nvSpPr>
+        <p:spPr>
+          <a:xfrm>
+            <a:off x="384048" y="219456"/>
+            <a:ext cx="11423599" cy="457200"/>
+          </a:xfrm>
+          <a:prstGeom prst="rect">
+            <a:avLst/>
+          </a:prstGeom>
+          <a:noFill/>
+        </p:spPr>
+        <p:txBody>
+          <a:bodyPr wrap="none">
+            <a:spAutoFit/>
+          </a:bodyPr>
+          <a:lstStyle/>
+          <a:p>
+            <a:r>
+              <a:rPr sz="2000" b="1" i="0" baseline="0">
+                <a:latin typeface="Calibri"/>
+              </a:rPr>
+              <a:t>Cold limit — rule C vs rule D</a:t>
+            </a:r>
+          </a:p>
+        </p:txBody>
+      </p:sp>
+      <mc:AlternateContent xmlns:mc="http://schemas.openxmlformats.org/markup-compatibility/2006">
+        <mc:Choice xmlns:a14="http://schemas.microsoft.com/office/drawing/2010/main" Requires="a14">
+          <p:sp>
+            <p:nvSpPr>
+              <p:cNvPr id="3" name="TextBox 2"/>
+              <p:cNvSpPr txBox="1"/>
+              <p:nvPr/>
+            </p:nvSpPr>
+            <p:spPr>
+              <a:xfrm>
+                <a:off x="384048" y="713232"/>
+                <a:ext cx="2453107" cy="307777"/>
+              </a:xfrm>
+              <a:prstGeom prst="rect">
+                <a:avLst/>
+              </a:prstGeom>
+              <a:noFill/>
+            </p:spPr>
+            <p:txBody>
+              <a:bodyPr wrap="none">
+                <a:spAutoFit/>
+              </a:bodyPr>
+              <a:lstStyle/>
+              <a:p>
+                <a14:m>
+                  <m:oMath xmlns:m="http://schemas.openxmlformats.org/officeDocument/2006/math">
+                    <m:r>
+                      <a:rPr lang="en-US" sz="1400" b="0" i="0" baseline="0" dirty="0" smtClean="0">
+                        <a:latin typeface="Cambria Math" panose="02040503050406030204" pitchFamily="18" charset="0"/>
+                      </a:rPr>
+                      <m:t>𝜆</m:t>
+                    </m:r>
+                    <m:r>
+                      <a:rPr lang="en-US" sz="1400" b="0" i="0" baseline="0" dirty="0" smtClean="0">
+                        <a:latin typeface="Cambria Math" panose="02040503050406030204" pitchFamily="18" charset="0"/>
+                      </a:rPr>
+                      <m:t>=2</m:t>
+                    </m:r>
+                  </m:oMath>
+                </a14:m>
+                <a:r>
+                  <a:rPr sz="1400" b="0" i="0" baseline="0" dirty="0">
+                    <a:latin typeface="Calibri"/>
+                  </a:rPr>
+                  <a:t> · </a:t>
+                </a:r>
+                <a14:m>
+                  <m:oMath xmlns:m="http://schemas.openxmlformats.org/officeDocument/2006/math">
+                    <m:r>
+                      <a:rPr lang="en-US" sz="1400" b="0" i="0" baseline="0" dirty="0" smtClean="0">
+                        <a:latin typeface="Cambria Math" panose="02040503050406030204" pitchFamily="18" charset="0"/>
+                      </a:rPr>
+                      <m:t>𝑡</m:t>
+                    </m:r>
+                    <m:r>
+                      <a:rPr lang="en-US" sz="1400" b="0" i="0" baseline="0" dirty="0" smtClean="0">
+                        <a:latin typeface="Cambria Math" panose="02040503050406030204" pitchFamily="18" charset="0"/>
+                      </a:rPr>
+                      <m:t>=0.001</m:t>
+                    </m:r>
+                  </m:oMath>
+                </a14:m>
+                <a:r>
+                  <a:rPr sz="1400" b="0" i="0" baseline="0" dirty="0">
+                    <a:latin typeface="Calibri"/>
+                  </a:rPr>
+                  <a:t> · same seeds</a:t>
+                </a:r>
+              </a:p>
+            </p:txBody>
+          </p:sp>
+        </mc:Choice>
+        <mc:Fallback>
+          <p:sp>
+            <p:nvSpPr>
+              <p:cNvPr id="3" name="TextBox 2"/>
+              <p:cNvSpPr txBox="1">
+                <a:spLocks noRot="1" noChangeAspect="1" noMove="1" noResize="1" noEditPoints="1" noAdjustHandles="1" noChangeArrowheads="1" noChangeShapeType="1" noTextEdit="1"/>
+              </p:cNvSpPr>
+              <p:nvPr/>
+            </p:nvSpPr>
+            <p:spPr>
+              <a:xfrm>
+                <a:off x="384048" y="713232"/>
+                <a:ext cx="2453107" cy="307777"/>
+              </a:xfrm>
+              <a:prstGeom prst="rect">
+                <a:avLst/>
+              </a:prstGeom>
+              <a:blipFill>
+                <a:blip r:embed="rId2"/>
+                <a:stretch>
+                  <a:fillRect t="-4000" b="-20000"/>
+                </a:stretch>
+              </a:blipFill>
+            </p:spPr>
+            <p:txBody>
+              <a:bodyPr/>
+              <a:lstStyle/>
+              <a:p>
+                <a:r>
+                  <a:rPr lang="en-US">
+                    <a:noFill/>
+                  </a:rPr>
+                  <a:t> </a:t>
+                </a:r>
+              </a:p>
+            </p:txBody>
+          </p:sp>
+        </mc:Fallback>
+      </mc:AlternateContent>
+      <p:pic>
+        <p:nvPicPr>
+          <p:cNvPr id="4" name="Picture 3"/>
+          <p:cNvPicPr>
+            <a:picLocks noChangeAspect="1"/>
+          </p:cNvPicPr>
+          <p:nvPr/>
+        </p:nvPicPr>
+        <p:blipFill>
+          <a:blip r:embed="rId3"/>
+          <a:srcRect/>
+          <a:stretch/>
+        </p:blipFill>
+        <p:spPr>
+          <a:xfrm>
+            <a:off x="1517482" y="993753"/>
+            <a:ext cx="9157036" cy="3874131"/>
+          </a:xfrm>
+          <a:prstGeom prst="rect">
+            <a:avLst/>
+          </a:prstGeom>
+        </p:spPr>
+      </p:pic>
+      <mc:AlternateContent xmlns:mc="http://schemas.openxmlformats.org/markup-compatibility/2006">
+        <mc:Choice xmlns:a14="http://schemas.microsoft.com/office/drawing/2010/main" Requires="a14">
+          <p:sp>
+            <p:nvSpPr>
+              <p:cNvPr id="5" name="TextBox 4"/>
+              <p:cNvSpPr txBox="1"/>
+              <p:nvPr/>
+            </p:nvSpPr>
+            <p:spPr>
+              <a:xfrm>
+                <a:off x="1144699" y="5160305"/>
+                <a:ext cx="11663172" cy="802901"/>
+              </a:xfrm>
+              <a:prstGeom prst="rect">
+                <a:avLst/>
+              </a:prstGeom>
+              <a:noFill/>
+            </p:spPr>
+            <p:txBody>
+              <a:bodyPr wrap="square" numCol="2">
+                <a:noAutofit/>
+              </a:bodyPr>
+              <a:lstStyle/>
+              <a:p>
+                <a:pPr>
+                  <a:lnSpc>
+                    <a:spcPct val="150000"/>
+                  </a:lnSpc>
+                  <a:buChar char="•"/>
+                </a:pPr>
+                <a:r>
+                  <a:rPr sz="1000" b="0" i="0" baseline="0" dirty="0">
+                    <a:latin typeface="Calibri"/>
+                  </a:rPr>
+                  <a:t>  Same ASSIGN seeds; only SELECT rule differs (C = top-</a:t>
+                </a:r>
+                <a14:m>
+                  <m:oMath xmlns:m="http://schemas.openxmlformats.org/officeDocument/2006/math">
+                    <m:r>
+                      <a:rPr lang="en-US" sz="1000" b="0" i="0" baseline="0" dirty="0" smtClean="0">
+                        <a:latin typeface="Cambria Math" panose="02040503050406030204" pitchFamily="18" charset="0"/>
+                      </a:rPr>
+                      <m:t>𝐾</m:t>
+                    </m:r>
+                  </m:oMath>
+                </a14:m>
+                <a:r>
+                  <a:rPr sz="1000" b="0" i="0" baseline="0" dirty="0">
+                    <a:latin typeface="Calibri"/>
+                  </a:rPr>
+                  <a:t>, D = cold Gibbs).</a:t>
+                </a:r>
+              </a:p>
+              <a:p>
+                <a:pPr>
+                  <a:lnSpc>
+                    <a:spcPct val="150000"/>
+                  </a:lnSpc>
+                  <a:buChar char="•"/>
+                </a:pPr>
+                <a:r>
+                  <a:rPr sz="1000" b="0" i="0" baseline="0" dirty="0">
+                    <a:latin typeface="Calibri"/>
+                  </a:rPr>
+                  <a:t>  Fixed </a:t>
+                </a:r>
+                <a14:m>
+                  <m:oMath xmlns:m="http://schemas.openxmlformats.org/officeDocument/2006/math">
+                    <m:r>
+                      <a:rPr lang="en-US" sz="1000" b="0" i="0" baseline="0" dirty="0" smtClean="0">
+                        <a:latin typeface="Cambria Math" panose="02040503050406030204" pitchFamily="18" charset="0"/>
+                      </a:rPr>
+                      <m:t>𝜆</m:t>
+                    </m:r>
+                    <m:r>
+                      <a:rPr lang="en-US" sz="1000" b="0" i="0" baseline="0" dirty="0" smtClean="0">
+                        <a:latin typeface="Cambria Math" panose="02040503050406030204" pitchFamily="18" charset="0"/>
+                      </a:rPr>
+                      <m:t>=2</m:t>
+                    </m:r>
+                  </m:oMath>
+                </a14:m>
+                <a:r>
+                  <a:rPr sz="1000" b="0" i="0" baseline="0" dirty="0">
+                    <a:latin typeface="Calibri"/>
+                  </a:rPr>
+                  <a:t>, </a:t>
+                </a:r>
+                <a14:m>
+                  <m:oMath xmlns:m="http://schemas.openxmlformats.org/officeDocument/2006/math">
+                    <m:r>
+                      <a:rPr lang="en-US" sz="1000" b="0" i="0" baseline="0" dirty="0" smtClean="0">
+                        <a:latin typeface="Cambria Math" panose="02040503050406030204" pitchFamily="18" charset="0"/>
+                      </a:rPr>
+                      <m:t>𝑡</m:t>
+                    </m:r>
+                    <m:r>
+                      <a:rPr lang="en-US" sz="1000" b="0" i="0" baseline="0" dirty="0" smtClean="0">
+                        <a:latin typeface="Cambria Math" panose="02040503050406030204" pitchFamily="18" charset="0"/>
+                      </a:rPr>
+                      <m:t>=0.001</m:t>
+                    </m:r>
+                  </m:oMath>
+                </a14:m>
+                <a:r>
+                  <a:rPr sz="1000" b="0" i="0" baseline="0" dirty="0">
+                    <a:latin typeface="Calibri"/>
+                  </a:rPr>
+                  <a:t> (</a:t>
+                </a:r>
+                <a14:m>
+                  <m:oMath xmlns:m="http://schemas.openxmlformats.org/officeDocument/2006/math">
+                    <m:func>
+                      <m:funcPr>
+                        <m:ctrlPr>
+                          <a:rPr lang="en-US" sz="1000" b="0" i="0" baseline="0" dirty="0">
+                            <a:latin typeface="Cambria Math" panose="02040503050406030204" pitchFamily="18" charset="0"/>
+                          </a:rPr>
+                        </m:ctrlPr>
+                      </m:funcPr>
+                      <m:fName>
+                        <m:sSub>
+                          <m:sSubPr>
+                            <m:ctrlPr>
+                              <a:rPr lang="en-US" sz="1000" b="0" i="0" baseline="0" dirty="0">
+                                <a:latin typeface="Cambria Math" panose="02040503050406030204" pitchFamily="18" charset="0"/>
+                              </a:rPr>
+                            </m:ctrlPr>
+                          </m:sSubPr>
+                          <m:e>
+                            <m:r>
+                              <m:rPr>
+                                <m:sty m:val="p"/>
+                              </m:rPr>
+                              <a:rPr lang="en-US" sz="1000" b="0" i="0" baseline="0" dirty="0">
+                                <a:latin typeface="Cambria Math" panose="02040503050406030204" pitchFamily="18" charset="0"/>
+                              </a:rPr>
+                              <m:t>log</m:t>
+                            </m:r>
+                          </m:e>
+                          <m:sub>
+                            <m:r>
+                              <a:rPr lang="en-US" sz="1000" b="0" i="0" baseline="0" dirty="0">
+                                <a:latin typeface="Cambria Math" panose="02040503050406030204" pitchFamily="18" charset="0"/>
+                              </a:rPr>
+                              <m:t>10</m:t>
+                            </m:r>
+                          </m:sub>
+                        </m:sSub>
+                      </m:fName>
+                      <m:e>
+                        <m:r>
+                          <a:rPr lang="en-US" sz="1000" b="0" i="0" baseline="0" dirty="0">
+                            <a:latin typeface="Cambria Math" panose="02040503050406030204" pitchFamily="18" charset="0"/>
+                          </a:rPr>
+                          <m:t>𝑡</m:t>
+                        </m:r>
+                      </m:e>
+                    </m:func>
+                    <m:r>
+                      <a:rPr lang="en-US" sz="1000" b="0" i="0" baseline="0" dirty="0">
+                        <a:latin typeface="Cambria Math" panose="02040503050406030204" pitchFamily="18" charset="0"/>
+                      </a:rPr>
+                      <m:t>=−3</m:t>
+                    </m:r>
+                  </m:oMath>
+                </a14:m>
+                <a:r>
+                  <a:rPr sz="1000" b="0" i="0" baseline="0" dirty="0">
+                    <a:latin typeface="Calibri"/>
+                  </a:rPr>
+                  <a:t>).</a:t>
+                </a:r>
+              </a:p>
+              <a:p>
+                <a:pPr>
+                  <a:lnSpc>
+                    <a:spcPct val="150000"/>
+                  </a:lnSpc>
+                  <a:buChar char="•"/>
+                </a:pPr>
+                <a:r>
+                  <a:rPr sz="1000" b="0" i="0" baseline="0" dirty="0">
+                    <a:latin typeface="Calibri"/>
+                  </a:rPr>
+                  <a:t>  Max bin gap C vs D: LOO = 0.00e+00, pool mean = 0.00e+00.</a:t>
+                </a:r>
+              </a:p>
+              <a:p>
+                <a:pPr>
+                  <a:lnSpc>
+                    <a:spcPct val="150000"/>
+                  </a:lnSpc>
+                  <a:buChar char="•"/>
+                </a:pPr>
+                <a:r>
+                  <a:rPr sz="1000" b="0" i="0" baseline="0" dirty="0">
+                    <a:latin typeface="Calibri"/>
+                  </a:rPr>
+                  <a:t>  LOO curvature: C = inverted u like; D = inverted u like.</a:t>
+                </a:r>
+              </a:p>
+              <a:p>
+                <a:pPr>
+                  <a:lnSpc>
+                    <a:spcPct val="150000"/>
+                  </a:lnSpc>
+                  <a:buChar char="•"/>
+                </a:pPr>
+                <a:r>
+                  <a:rPr sz="1000" b="0" i="0" baseline="0" dirty="0">
+                    <a:latin typeface="Calibri"/>
+                  </a:rPr>
+                  <a:t>  Expect overlay coincidence at cold </a:t>
+                </a:r>
+                <a14:m>
+                  <m:oMath xmlns:m="http://schemas.openxmlformats.org/officeDocument/2006/math">
+                    <m:r>
+                      <a:rPr lang="en-US" sz="1000" b="0" i="0" baseline="0" dirty="0" smtClean="0">
+                        <a:latin typeface="Cambria Math" panose="02040503050406030204" pitchFamily="18" charset="0"/>
+                      </a:rPr>
+                      <m:t>𝑡</m:t>
+                    </m:r>
+                  </m:oMath>
+                </a14:m>
+                <a:r>
+                  <a:rPr sz="1000" b="0" i="0" baseline="0" dirty="0">
+                    <a:latin typeface="Calibri"/>
+                  </a:rPr>
+                  <a:t> (Gibbs </a:t>
+                </a:r>
+                <a14:m>
+                  <m:oMath xmlns:m="http://schemas.openxmlformats.org/officeDocument/2006/math">
+                    <m:r>
+                      <a:rPr lang="en-US" sz="1000" b="0" i="0" baseline="0" dirty="0" smtClean="0">
+                        <a:latin typeface="Cambria Math" panose="02040503050406030204" pitchFamily="18" charset="0"/>
+                      </a:rPr>
+                      <m:t>→</m:t>
+                    </m:r>
+                  </m:oMath>
+                </a14:m>
+                <a:r>
+                  <a:rPr sz="1000" b="0" i="0" baseline="0" dirty="0">
+                    <a:latin typeface="Calibri"/>
+                  </a:rPr>
+                  <a:t> hard ranking).</a:t>
+                </a:r>
+              </a:p>
+              <a:p>
+                <a:pPr>
+                  <a:lnSpc>
+                    <a:spcPct val="150000"/>
+                  </a:lnSpc>
+                  <a:buChar char="•"/>
+                </a:pPr>
+                <a:r>
+                  <a:rPr sz="1000" b="0" i="0" baseline="0" dirty="0">
+                    <a:latin typeface="Calibri"/>
+                  </a:rPr>
+                  <a:t>  Numerical match flag: True (gap </a:t>
+                </a:r>
+                <a14:m>
+                  <m:oMath xmlns:m="http://schemas.openxmlformats.org/officeDocument/2006/math">
+                    <m:r>
+                      <a:rPr lang="en-US" sz="1000" b="0" i="0" baseline="0" dirty="0" smtClean="0">
+                        <a:latin typeface="Cambria Math" panose="02040503050406030204" pitchFamily="18" charset="0"/>
+                      </a:rPr>
+                      <m:t>&lt;</m:t>
+                    </m:r>
+                    <m:sSup>
+                      <m:sSupPr>
+                        <m:ctrlPr>
+                          <a:rPr lang="en-US" sz="1000" b="0" i="0" baseline="0" dirty="0">
+                            <a:latin typeface="Cambria Math" panose="02040503050406030204" pitchFamily="18" charset="0"/>
+                          </a:rPr>
+                        </m:ctrlPr>
+                      </m:sSupPr>
+                      <m:e>
+                        <m:r>
+                          <a:rPr lang="en-US" sz="1000" b="0" i="0" baseline="0" dirty="0">
+                            <a:latin typeface="Cambria Math" panose="02040503050406030204" pitchFamily="18" charset="0"/>
+                          </a:rPr>
+                          <m:t>10</m:t>
+                        </m:r>
+                      </m:e>
+                      <m:sup>
+                        <m:r>
+                          <a:rPr lang="en-US" sz="1000" b="0" i="0" baseline="0" dirty="0">
+                            <a:latin typeface="Cambria Math" panose="02040503050406030204" pitchFamily="18" charset="0"/>
+                          </a:rPr>
+                          <m:t>−9</m:t>
+                        </m:r>
+                      </m:sup>
+                    </m:sSup>
+                  </m:oMath>
+                </a14:m>
+                <a:r>
+                  <a:rPr sz="1000" b="0" i="0" baseline="0" dirty="0">
+                    <a:latin typeface="Calibri"/>
+                  </a:rPr>
+                  <a:t> on binned curves).</a:t>
+                </a:r>
+              </a:p>
+            </p:txBody>
+          </p:sp>
+        </mc:Choice>
+        <mc:Fallback>
+          <p:sp>
+            <p:nvSpPr>
+              <p:cNvPr id="5" name="TextBox 4"/>
+              <p:cNvSpPr txBox="1">
+                <a:spLocks noRot="1" noChangeAspect="1" noMove="1" noResize="1" noEditPoints="1" noAdjustHandles="1" noChangeArrowheads="1" noChangeShapeType="1" noTextEdit="1"/>
+              </p:cNvSpPr>
+              <p:nvPr/>
+            </p:nvSpPr>
+            <p:spPr>
+              <a:xfrm>
+                <a:off x="1144699" y="5160305"/>
+                <a:ext cx="11663172" cy="802901"/>
+              </a:xfrm>
+              <a:prstGeom prst="rect">
+                <a:avLst/>
+              </a:prstGeom>
+              <a:blipFill>
+                <a:blip r:embed="rId4"/>
+                <a:stretch>
+                  <a:fillRect/>
+                </a:stretch>
+              </a:blipFill>
+            </p:spPr>
+            <p:txBody>
+              <a:bodyPr/>
+              <a:lstStyle/>
+              <a:p>
+                <a:r>
+                  <a:rPr lang="en-US">
+                    <a:noFill/>
+                  </a:rPr>
+                  <a:t> </a:t>
+                </a:r>
+              </a:p>
+            </p:txBody>
+          </p:sp>
+        </mc:Fallback>
+      </mc:AlternateContent>
+      <mc:AlternateContent xmlns:mc="http://schemas.openxmlformats.org/markup-compatibility/2006">
+        <mc:Choice xmlns:a14="http://schemas.microsoft.com/office/drawing/2010/main" Requires="a14">
+          <p:sp>
+            <p:nvSpPr>
+              <p:cNvPr id="6" name="TextBox 5"/>
+              <p:cNvSpPr txBox="1"/>
+              <p:nvPr/>
+            </p:nvSpPr>
+            <p:spPr>
+              <a:xfrm>
+                <a:off x="384048" y="6053328"/>
+                <a:ext cx="6199389" cy="261610"/>
+              </a:xfrm>
+              <a:prstGeom prst="rect">
+                <a:avLst/>
+              </a:prstGeom>
+              <a:noFill/>
+            </p:spPr>
+            <p:txBody>
+              <a:bodyPr wrap="none">
+                <a:spAutoFit/>
+              </a:bodyPr>
+              <a:lstStyle/>
+              <a:p>
+                <a:pPr algn="l"/>
+                <a:r>
+                  <a:rPr sz="1100" b="1" i="0" baseline="0" dirty="0">
+                    <a:latin typeface="Calibri"/>
+                  </a:rPr>
+                  <a:t>Talking point: rule D at cold </a:t>
+                </a:r>
+                <a14:m>
+                  <m:oMath xmlns:m="http://schemas.openxmlformats.org/officeDocument/2006/math">
+                    <m:r>
+                      <a:rPr lang="en-US" sz="1100" b="1" i="0" baseline="0" dirty="0" smtClean="0">
+                        <a:latin typeface="Cambria Math" panose="02040503050406030204" pitchFamily="18" charset="0"/>
+                      </a:rPr>
+                      <m:t>𝑡</m:t>
+                    </m:r>
+                  </m:oMath>
+                </a14:m>
+                <a:r>
+                  <a:rPr sz="1100" b="1" i="0" baseline="0" dirty="0">
+                    <a:latin typeface="Calibri"/>
+                  </a:rPr>
+                  <a:t> reproduces rule C bin-for-bin — Gibbs SELECT nests the old top-</a:t>
+                </a:r>
+                <a14:m>
+                  <m:oMath xmlns:m="http://schemas.openxmlformats.org/officeDocument/2006/math">
+                    <m:r>
+                      <a:rPr lang="en-US" sz="1100" b="1" i="0" baseline="0" dirty="0" smtClean="0">
+                        <a:latin typeface="Cambria Math" panose="02040503050406030204" pitchFamily="18" charset="0"/>
+                      </a:rPr>
+                      <m:t>𝐾</m:t>
+                    </m:r>
+                  </m:oMath>
+                </a14:m>
+                <a:r>
+                  <a:rPr sz="1100" b="1" i="0" baseline="0" dirty="0">
+                    <a:latin typeface="Calibri"/>
+                  </a:rPr>
+                  <a:t> limit.</a:t>
+                </a:r>
+              </a:p>
+            </p:txBody>
+          </p:sp>
+        </mc:Choice>
+        <mc:Fallback>
+          <p:sp>
+            <p:nvSpPr>
+              <p:cNvPr id="6" name="TextBox 5"/>
+              <p:cNvSpPr txBox="1">
+                <a:spLocks noRot="1" noChangeAspect="1" noMove="1" noResize="1" noEditPoints="1" noAdjustHandles="1" noChangeArrowheads="1" noChangeShapeType="1" noTextEdit="1"/>
+              </p:cNvSpPr>
+              <p:nvPr/>
+            </p:nvSpPr>
+            <p:spPr>
+              <a:xfrm>
+                <a:off x="384048" y="6053328"/>
+                <a:ext cx="6199389" cy="261610"/>
+              </a:xfrm>
+              <a:prstGeom prst="rect">
+                <a:avLst/>
+              </a:prstGeom>
+              <a:blipFill>
+                <a:blip r:embed="rId5"/>
                 <a:stretch>
                   <a:fillRect b="-13636"/>
                 </a:stretch>
@@ -5072,648 +5633,6 @@
               <a:rPr sz="2000" b="1" i="0" baseline="0">
                 <a:latin typeface="Calibri"/>
               </a:rPr>
-              <a:t>Cold limit — rule C vs rule D</a:t>
-            </a:r>
-          </a:p>
-        </p:txBody>
-      </p:sp>
-      <mc:AlternateContent xmlns:mc="http://schemas.openxmlformats.org/markup-compatibility/2006">
-        <mc:Choice xmlns:a14="http://schemas.microsoft.com/office/drawing/2010/main" Requires="a14">
-          <p:sp>
-            <p:nvSpPr>
-              <p:cNvPr id="3" name="TextBox 2"/>
-              <p:cNvSpPr txBox="1"/>
-              <p:nvPr/>
-            </p:nvSpPr>
-            <p:spPr>
-              <a:xfrm>
-                <a:off x="384048" y="713232"/>
-                <a:ext cx="2453107" cy="307777"/>
-              </a:xfrm>
-              <a:prstGeom prst="rect">
-                <a:avLst/>
-              </a:prstGeom>
-              <a:noFill/>
-            </p:spPr>
-            <p:txBody>
-              <a:bodyPr wrap="none">
-                <a:spAutoFit/>
-              </a:bodyPr>
-              <a:lstStyle/>
-              <a:p>
-                <a14:m>
-                  <m:oMath xmlns:m="http://schemas.openxmlformats.org/officeDocument/2006/math">
-                    <m:r>
-                      <a:rPr lang="en-US" sz="1400" b="0" i="0" baseline="0" dirty="0" smtClean="0">
-                        <a:latin typeface="Cambria Math" panose="02040503050406030204" pitchFamily="18" charset="0"/>
-                      </a:rPr>
-                      <m:t>𝜆</m:t>
-                    </m:r>
-                    <m:r>
-                      <a:rPr lang="en-US" sz="1400" b="0" i="0" baseline="0" dirty="0" smtClean="0">
-                        <a:latin typeface="Cambria Math" panose="02040503050406030204" pitchFamily="18" charset="0"/>
-                      </a:rPr>
-                      <m:t>=2</m:t>
-                    </m:r>
-                  </m:oMath>
-                </a14:m>
-                <a:r>
-                  <a:rPr sz="1400" b="0" i="0" baseline="0" dirty="0">
-                    <a:latin typeface="Calibri"/>
-                  </a:rPr>
-                  <a:t> · </a:t>
-                </a:r>
-                <a14:m>
-                  <m:oMath xmlns:m="http://schemas.openxmlformats.org/officeDocument/2006/math">
-                    <m:r>
-                      <a:rPr lang="en-US" sz="1400" b="0" i="0" baseline="0" dirty="0" smtClean="0">
-                        <a:latin typeface="Cambria Math" panose="02040503050406030204" pitchFamily="18" charset="0"/>
-                      </a:rPr>
-                      <m:t>𝑡</m:t>
-                    </m:r>
-                    <m:r>
-                      <a:rPr lang="en-US" sz="1400" b="0" i="0" baseline="0" dirty="0" smtClean="0">
-                        <a:latin typeface="Cambria Math" panose="02040503050406030204" pitchFamily="18" charset="0"/>
-                      </a:rPr>
-                      <m:t>=0.001</m:t>
-                    </m:r>
-                  </m:oMath>
-                </a14:m>
-                <a:r>
-                  <a:rPr sz="1400" b="0" i="0" baseline="0" dirty="0">
-                    <a:latin typeface="Calibri"/>
-                  </a:rPr>
-                  <a:t> · same seeds</a:t>
-                </a:r>
-              </a:p>
-            </p:txBody>
-          </p:sp>
-        </mc:Choice>
-        <mc:Fallback>
-          <p:sp>
-            <p:nvSpPr>
-              <p:cNvPr id="3" name="TextBox 2"/>
-              <p:cNvSpPr txBox="1">
-                <a:spLocks noRot="1" noChangeAspect="1" noMove="1" noResize="1" noEditPoints="1" noAdjustHandles="1" noChangeArrowheads="1" noChangeShapeType="1" noTextEdit="1"/>
-              </p:cNvSpPr>
-              <p:nvPr/>
-            </p:nvSpPr>
-            <p:spPr>
-              <a:xfrm>
-                <a:off x="384048" y="713232"/>
-                <a:ext cx="2453107" cy="307777"/>
-              </a:xfrm>
-              <a:prstGeom prst="rect">
-                <a:avLst/>
-              </a:prstGeom>
-              <a:blipFill>
-                <a:blip r:embed="rId2"/>
-                <a:stretch>
-                  <a:fillRect t="-4000" b="-20000"/>
-                </a:stretch>
-              </a:blipFill>
-            </p:spPr>
-            <p:txBody>
-              <a:bodyPr/>
-              <a:lstStyle/>
-              <a:p>
-                <a:r>
-                  <a:rPr lang="en-US">
-                    <a:noFill/>
-                  </a:rPr>
-                  <a:t> </a:t>
-                </a:r>
-              </a:p>
-            </p:txBody>
-          </p:sp>
-        </mc:Fallback>
-      </mc:AlternateContent>
-      <p:pic>
-        <p:nvPicPr>
-          <p:cNvPr id="4" name="Picture 3" descr="GRANDCHILD_temperature_cold_limit_2011_2021.png"/>
-          <p:cNvPicPr>
-            <a:picLocks noChangeAspect="1"/>
-          </p:cNvPicPr>
-          <p:nvPr/>
-        </p:nvPicPr>
-        <p:blipFill>
-          <a:blip r:embed="rId3"/>
-          <a:stretch>
-            <a:fillRect/>
-          </a:stretch>
-        </p:blipFill>
-        <p:spPr>
-          <a:xfrm>
-            <a:off x="1440247" y="993753"/>
-            <a:ext cx="9311507" cy="3874131"/>
-          </a:xfrm>
-          <a:prstGeom prst="rect">
-            <a:avLst/>
-          </a:prstGeom>
-        </p:spPr>
-      </p:pic>
-      <mc:AlternateContent xmlns:mc="http://schemas.openxmlformats.org/markup-compatibility/2006">
-        <mc:Choice xmlns:a14="http://schemas.microsoft.com/office/drawing/2010/main" Requires="a14">
-          <p:sp>
-            <p:nvSpPr>
-              <p:cNvPr id="5" name="TextBox 4"/>
-              <p:cNvSpPr txBox="1"/>
-              <p:nvPr/>
-            </p:nvSpPr>
-            <p:spPr>
-              <a:xfrm>
-                <a:off x="1144699" y="5160305"/>
-                <a:ext cx="11663172" cy="802901"/>
-              </a:xfrm>
-              <a:prstGeom prst="rect">
-                <a:avLst/>
-              </a:prstGeom>
-              <a:noFill/>
-            </p:spPr>
-            <p:txBody>
-              <a:bodyPr wrap="square" numCol="2">
-                <a:noAutofit/>
-              </a:bodyPr>
-              <a:lstStyle/>
-              <a:p>
-                <a:pPr>
-                  <a:lnSpc>
-                    <a:spcPct val="150000"/>
-                  </a:lnSpc>
-                  <a:buChar char="•"/>
-                </a:pPr>
-                <a:r>
-                  <a:rPr sz="1000" b="0" i="0" baseline="0" dirty="0">
-                    <a:latin typeface="Calibri"/>
-                  </a:rPr>
-                  <a:t>  Same ASSIGN seeds; only SELECT rule differs (C = top-</a:t>
-                </a:r>
-                <a14:m>
-                  <m:oMath xmlns:m="http://schemas.openxmlformats.org/officeDocument/2006/math">
-                    <m:r>
-                      <a:rPr lang="en-US" sz="1000" b="0" i="0" baseline="0" dirty="0" smtClean="0">
-                        <a:latin typeface="Cambria Math" panose="02040503050406030204" pitchFamily="18" charset="0"/>
-                      </a:rPr>
-                      <m:t>𝐾</m:t>
-                    </m:r>
-                  </m:oMath>
-                </a14:m>
-                <a:r>
-                  <a:rPr sz="1000" b="0" i="0" baseline="0" dirty="0">
-                    <a:latin typeface="Calibri"/>
-                  </a:rPr>
-                  <a:t>, D = cold Gibbs).</a:t>
-                </a:r>
-              </a:p>
-              <a:p>
-                <a:pPr>
-                  <a:lnSpc>
-                    <a:spcPct val="150000"/>
-                  </a:lnSpc>
-                  <a:buChar char="•"/>
-                </a:pPr>
-                <a:r>
-                  <a:rPr sz="1000" b="0" i="0" baseline="0" dirty="0">
-                    <a:latin typeface="Calibri"/>
-                  </a:rPr>
-                  <a:t>  Fixed </a:t>
-                </a:r>
-                <a14:m>
-                  <m:oMath xmlns:m="http://schemas.openxmlformats.org/officeDocument/2006/math">
-                    <m:r>
-                      <a:rPr lang="en-US" sz="1000" b="0" i="0" baseline="0" dirty="0" smtClean="0">
-                        <a:latin typeface="Cambria Math" panose="02040503050406030204" pitchFamily="18" charset="0"/>
-                      </a:rPr>
-                      <m:t>𝜆</m:t>
-                    </m:r>
-                    <m:r>
-                      <a:rPr lang="en-US" sz="1000" b="0" i="0" baseline="0" dirty="0" smtClean="0">
-                        <a:latin typeface="Cambria Math" panose="02040503050406030204" pitchFamily="18" charset="0"/>
-                      </a:rPr>
-                      <m:t>=2</m:t>
-                    </m:r>
-                  </m:oMath>
-                </a14:m>
-                <a:r>
-                  <a:rPr sz="1000" b="0" i="0" baseline="0" dirty="0">
-                    <a:latin typeface="Calibri"/>
-                  </a:rPr>
-                  <a:t>, </a:t>
-                </a:r>
-                <a14:m>
-                  <m:oMath xmlns:m="http://schemas.openxmlformats.org/officeDocument/2006/math">
-                    <m:r>
-                      <a:rPr lang="en-US" sz="1000" b="0" i="0" baseline="0" dirty="0" smtClean="0">
-                        <a:latin typeface="Cambria Math" panose="02040503050406030204" pitchFamily="18" charset="0"/>
-                      </a:rPr>
-                      <m:t>𝑡</m:t>
-                    </m:r>
-                    <m:r>
-                      <a:rPr lang="en-US" sz="1000" b="0" i="0" baseline="0" dirty="0" smtClean="0">
-                        <a:latin typeface="Cambria Math" panose="02040503050406030204" pitchFamily="18" charset="0"/>
-                      </a:rPr>
-                      <m:t>=0.001</m:t>
-                    </m:r>
-                  </m:oMath>
-                </a14:m>
-                <a:r>
-                  <a:rPr sz="1000" b="0" i="0" baseline="0" dirty="0">
-                    <a:latin typeface="Calibri"/>
-                  </a:rPr>
-                  <a:t> (</a:t>
-                </a:r>
-                <a14:m>
-                  <m:oMath xmlns:m="http://schemas.openxmlformats.org/officeDocument/2006/math">
-                    <m:func>
-                      <m:funcPr>
-                        <m:ctrlPr>
-                          <a:rPr lang="en-US" sz="1000" b="0" i="0" baseline="0" dirty="0">
-                            <a:latin typeface="Cambria Math" panose="02040503050406030204" pitchFamily="18" charset="0"/>
-                          </a:rPr>
-                        </m:ctrlPr>
-                      </m:funcPr>
-                      <m:fName>
-                        <m:sSub>
-                          <m:sSubPr>
-                            <m:ctrlPr>
-                              <a:rPr lang="en-US" sz="1000" b="0" i="0" baseline="0" dirty="0">
-                                <a:latin typeface="Cambria Math" panose="02040503050406030204" pitchFamily="18" charset="0"/>
-                              </a:rPr>
-                            </m:ctrlPr>
-                          </m:sSubPr>
-                          <m:e>
-                            <m:r>
-                              <m:rPr>
-                                <m:sty m:val="p"/>
-                              </m:rPr>
-                              <a:rPr lang="en-US" sz="1000" b="0" i="0" baseline="0" dirty="0">
-                                <a:latin typeface="Cambria Math" panose="02040503050406030204" pitchFamily="18" charset="0"/>
-                              </a:rPr>
-                              <m:t>log</m:t>
-                            </m:r>
-                          </m:e>
-                          <m:sub>
-                            <m:r>
-                              <a:rPr lang="en-US" sz="1000" b="0" i="0" baseline="0" dirty="0">
-                                <a:latin typeface="Cambria Math" panose="02040503050406030204" pitchFamily="18" charset="0"/>
-                              </a:rPr>
-                              <m:t>10</m:t>
-                            </m:r>
-                          </m:sub>
-                        </m:sSub>
-                      </m:fName>
-                      <m:e>
-                        <m:r>
-                          <a:rPr lang="en-US" sz="1000" b="0" i="0" baseline="0" dirty="0">
-                            <a:latin typeface="Cambria Math" panose="02040503050406030204" pitchFamily="18" charset="0"/>
-                          </a:rPr>
-                          <m:t>𝑡</m:t>
-                        </m:r>
-                      </m:e>
-                    </m:func>
-                    <m:r>
-                      <a:rPr lang="en-US" sz="1000" b="0" i="0" baseline="0" dirty="0">
-                        <a:latin typeface="Cambria Math" panose="02040503050406030204" pitchFamily="18" charset="0"/>
-                      </a:rPr>
-                      <m:t>=−3</m:t>
-                    </m:r>
-                  </m:oMath>
-                </a14:m>
-                <a:r>
-                  <a:rPr sz="1000" b="0" i="0" baseline="0" dirty="0">
-                    <a:latin typeface="Calibri"/>
-                  </a:rPr>
-                  <a:t>).</a:t>
-                </a:r>
-              </a:p>
-              <a:p>
-                <a:pPr>
-                  <a:lnSpc>
-                    <a:spcPct val="150000"/>
-                  </a:lnSpc>
-                  <a:buChar char="•"/>
-                </a:pPr>
-                <a:r>
-                  <a:rPr sz="1000" b="0" i="0" baseline="0" dirty="0">
-                    <a:latin typeface="Calibri"/>
-                  </a:rPr>
-                  <a:t>  Max bin gap C vs D: LOO = 0.00e+00, pool mean = 0.00e+00.</a:t>
-                </a:r>
-              </a:p>
-              <a:p>
-                <a:pPr>
-                  <a:lnSpc>
-                    <a:spcPct val="150000"/>
-                  </a:lnSpc>
-                  <a:buChar char="•"/>
-                </a:pPr>
-                <a:r>
-                  <a:rPr sz="1000" b="0" i="0" baseline="0" dirty="0">
-                    <a:latin typeface="Calibri"/>
-                  </a:rPr>
-                  <a:t>  LOO curvature: C = inverted u like; D = inverted u like.</a:t>
-                </a:r>
-              </a:p>
-              <a:p>
-                <a:pPr>
-                  <a:lnSpc>
-                    <a:spcPct val="150000"/>
-                  </a:lnSpc>
-                  <a:buChar char="•"/>
-                </a:pPr>
-                <a:r>
-                  <a:rPr sz="1000" b="0" i="0" baseline="0" dirty="0">
-                    <a:latin typeface="Calibri"/>
-                  </a:rPr>
-                  <a:t>  Expect overlay coincidence at cold </a:t>
-                </a:r>
-                <a14:m>
-                  <m:oMath xmlns:m="http://schemas.openxmlformats.org/officeDocument/2006/math">
-                    <m:r>
-                      <a:rPr lang="en-US" sz="1000" b="0" i="0" baseline="0" dirty="0" smtClean="0">
-                        <a:latin typeface="Cambria Math" panose="02040503050406030204" pitchFamily="18" charset="0"/>
-                      </a:rPr>
-                      <m:t>𝑡</m:t>
-                    </m:r>
-                  </m:oMath>
-                </a14:m>
-                <a:r>
-                  <a:rPr sz="1000" b="0" i="0" baseline="0" dirty="0">
-                    <a:latin typeface="Calibri"/>
-                  </a:rPr>
-                  <a:t> (Gibbs </a:t>
-                </a:r>
-                <a14:m>
-                  <m:oMath xmlns:m="http://schemas.openxmlformats.org/officeDocument/2006/math">
-                    <m:r>
-                      <a:rPr lang="en-US" sz="1000" b="0" i="0" baseline="0" dirty="0" smtClean="0">
-                        <a:latin typeface="Cambria Math" panose="02040503050406030204" pitchFamily="18" charset="0"/>
-                      </a:rPr>
-                      <m:t>→</m:t>
-                    </m:r>
-                  </m:oMath>
-                </a14:m>
-                <a:r>
-                  <a:rPr sz="1000" b="0" i="0" baseline="0" dirty="0">
-                    <a:latin typeface="Calibri"/>
-                  </a:rPr>
-                  <a:t> hard ranking).</a:t>
-                </a:r>
-              </a:p>
-              <a:p>
-                <a:pPr>
-                  <a:lnSpc>
-                    <a:spcPct val="150000"/>
-                  </a:lnSpc>
-                  <a:buChar char="•"/>
-                </a:pPr>
-                <a:r>
-                  <a:rPr sz="1000" b="0" i="0" baseline="0" dirty="0">
-                    <a:latin typeface="Calibri"/>
-                  </a:rPr>
-                  <a:t>  Numerical match flag: True (gap </a:t>
-                </a:r>
-                <a14:m>
-                  <m:oMath xmlns:m="http://schemas.openxmlformats.org/officeDocument/2006/math">
-                    <m:r>
-                      <a:rPr lang="en-US" sz="1000" b="0" i="0" baseline="0" dirty="0" smtClean="0">
-                        <a:latin typeface="Cambria Math" panose="02040503050406030204" pitchFamily="18" charset="0"/>
-                      </a:rPr>
-                      <m:t>&lt;</m:t>
-                    </m:r>
-                    <m:sSup>
-                      <m:sSupPr>
-                        <m:ctrlPr>
-                          <a:rPr lang="en-US" sz="1000" b="0" i="0" baseline="0" dirty="0">
-                            <a:latin typeface="Cambria Math" panose="02040503050406030204" pitchFamily="18" charset="0"/>
-                          </a:rPr>
-                        </m:ctrlPr>
-                      </m:sSupPr>
-                      <m:e>
-                        <m:r>
-                          <a:rPr lang="en-US" sz="1000" b="0" i="0" baseline="0" dirty="0">
-                            <a:latin typeface="Cambria Math" panose="02040503050406030204" pitchFamily="18" charset="0"/>
-                          </a:rPr>
-                          <m:t>10</m:t>
-                        </m:r>
-                      </m:e>
-                      <m:sup>
-                        <m:r>
-                          <a:rPr lang="en-US" sz="1000" b="0" i="0" baseline="0" dirty="0">
-                            <a:latin typeface="Cambria Math" panose="02040503050406030204" pitchFamily="18" charset="0"/>
-                          </a:rPr>
-                          <m:t>−9</m:t>
-                        </m:r>
-                      </m:sup>
-                    </m:sSup>
-                  </m:oMath>
-                </a14:m>
-                <a:r>
-                  <a:rPr sz="1000" b="0" i="0" baseline="0" dirty="0">
-                    <a:latin typeface="Calibri"/>
-                  </a:rPr>
-                  <a:t> on binned curves).</a:t>
-                </a:r>
-              </a:p>
-            </p:txBody>
-          </p:sp>
-        </mc:Choice>
-        <mc:Fallback>
-          <p:sp>
-            <p:nvSpPr>
-              <p:cNvPr id="5" name="TextBox 4"/>
-              <p:cNvSpPr txBox="1">
-                <a:spLocks noRot="1" noChangeAspect="1" noMove="1" noResize="1" noEditPoints="1" noAdjustHandles="1" noChangeArrowheads="1" noChangeShapeType="1" noTextEdit="1"/>
-              </p:cNvSpPr>
-              <p:nvPr/>
-            </p:nvSpPr>
-            <p:spPr>
-              <a:xfrm>
-                <a:off x="1144699" y="5160305"/>
-                <a:ext cx="11663172" cy="802901"/>
-              </a:xfrm>
-              <a:prstGeom prst="rect">
-                <a:avLst/>
-              </a:prstGeom>
-              <a:blipFill>
-                <a:blip r:embed="rId4"/>
-                <a:stretch>
-                  <a:fillRect/>
-                </a:stretch>
-              </a:blipFill>
-            </p:spPr>
-            <p:txBody>
-              <a:bodyPr/>
-              <a:lstStyle/>
-              <a:p>
-                <a:r>
-                  <a:rPr lang="en-US">
-                    <a:noFill/>
-                  </a:rPr>
-                  <a:t> </a:t>
-                </a:r>
-              </a:p>
-            </p:txBody>
-          </p:sp>
-        </mc:Fallback>
-      </mc:AlternateContent>
-      <mc:AlternateContent xmlns:mc="http://schemas.openxmlformats.org/markup-compatibility/2006">
-        <mc:Choice xmlns:a14="http://schemas.microsoft.com/office/drawing/2010/main" Requires="a14">
-          <p:sp>
-            <p:nvSpPr>
-              <p:cNvPr id="6" name="TextBox 5"/>
-              <p:cNvSpPr txBox="1"/>
-              <p:nvPr/>
-            </p:nvSpPr>
-            <p:spPr>
-              <a:xfrm>
-                <a:off x="384048" y="6053328"/>
-                <a:ext cx="6199389" cy="261610"/>
-              </a:xfrm>
-              <a:prstGeom prst="rect">
-                <a:avLst/>
-              </a:prstGeom>
-              <a:noFill/>
-            </p:spPr>
-            <p:txBody>
-              <a:bodyPr wrap="none">
-                <a:spAutoFit/>
-              </a:bodyPr>
-              <a:lstStyle/>
-              <a:p>
-                <a:pPr algn="l"/>
-                <a:r>
-                  <a:rPr sz="1100" b="1" i="0" baseline="0" dirty="0">
-                    <a:latin typeface="Calibri"/>
-                  </a:rPr>
-                  <a:t>Talking point: rule D at cold </a:t>
-                </a:r>
-                <a14:m>
-                  <m:oMath xmlns:m="http://schemas.openxmlformats.org/officeDocument/2006/math">
-                    <m:r>
-                      <a:rPr lang="en-US" sz="1100" b="1" i="0" baseline="0" dirty="0" smtClean="0">
-                        <a:latin typeface="Cambria Math" panose="02040503050406030204" pitchFamily="18" charset="0"/>
-                      </a:rPr>
-                      <m:t>𝑡</m:t>
-                    </m:r>
-                  </m:oMath>
-                </a14:m>
-                <a:r>
-                  <a:rPr sz="1100" b="1" i="0" baseline="0" dirty="0">
-                    <a:latin typeface="Calibri"/>
-                  </a:rPr>
-                  <a:t> reproduces rule C bin-for-bin — Gibbs SELECT nests the old top-</a:t>
-                </a:r>
-                <a14:m>
-                  <m:oMath xmlns:m="http://schemas.openxmlformats.org/officeDocument/2006/math">
-                    <m:r>
-                      <a:rPr lang="en-US" sz="1100" b="1" i="0" baseline="0" dirty="0" smtClean="0">
-                        <a:latin typeface="Cambria Math" panose="02040503050406030204" pitchFamily="18" charset="0"/>
-                      </a:rPr>
-                      <m:t>𝐾</m:t>
-                    </m:r>
-                  </m:oMath>
-                </a14:m>
-                <a:r>
-                  <a:rPr sz="1100" b="1" i="0" baseline="0" dirty="0">
-                    <a:latin typeface="Calibri"/>
-                  </a:rPr>
-                  <a:t> limit.</a:t>
-                </a:r>
-              </a:p>
-            </p:txBody>
-          </p:sp>
-        </mc:Choice>
-        <mc:Fallback>
-          <p:sp>
-            <p:nvSpPr>
-              <p:cNvPr id="6" name="TextBox 5"/>
-              <p:cNvSpPr txBox="1">
-                <a:spLocks noRot="1" noChangeAspect="1" noMove="1" noResize="1" noEditPoints="1" noAdjustHandles="1" noChangeArrowheads="1" noChangeShapeType="1" noTextEdit="1"/>
-              </p:cNvSpPr>
-              <p:nvPr/>
-            </p:nvSpPr>
-            <p:spPr>
-              <a:xfrm>
-                <a:off x="384048" y="6053328"/>
-                <a:ext cx="6199389" cy="261610"/>
-              </a:xfrm>
-              <a:prstGeom prst="rect">
-                <a:avLst/>
-              </a:prstGeom>
-              <a:blipFill>
-                <a:blip r:embed="rId5"/>
-                <a:stretch>
-                  <a:fillRect b="-13636"/>
-                </a:stretch>
-              </a:blipFill>
-            </p:spPr>
-            <p:txBody>
-              <a:bodyPr/>
-              <a:lstStyle/>
-              <a:p>
-                <a:r>
-                  <a:rPr lang="en-US">
-                    <a:noFill/>
-                  </a:rPr>
-                  <a:t> </a:t>
-                </a:r>
-              </a:p>
-            </p:txBody>
-          </p:sp>
-        </mc:Fallback>
-      </mc:AlternateContent>
-    </p:spTree>
-  </p:cSld>
-  <p:clrMapOvr>
-    <a:masterClrMapping/>
-  </p:clrMapOvr>
-</p:sld>
-</file>
-
-<file path=ppt/slides/slide5.xml><?xml version="1.0" encoding="utf-8"?>
-<p:sld xmlns:a="http://schemas.openxmlformats.org/drawingml/2006/main" xmlns:r="http://schemas.openxmlformats.org/officeDocument/2006/relationships" xmlns:p="http://schemas.openxmlformats.org/presentationml/2006/main">
-  <p:cSld>
-    <p:spTree>
-      <p:nvGrpSpPr>
-        <p:cNvPr id="1" name=""/>
-        <p:cNvGrpSpPr/>
-        <p:nvPr/>
-      </p:nvGrpSpPr>
-      <p:grpSpPr>
-        <a:xfrm>
-          <a:off x="0" y="0"/>
-          <a:ext cx="0" cy="0"/>
-          <a:chOff x="0" y="0"/>
-          <a:chExt cx="0" cy="0"/>
-        </a:xfrm>
-      </p:grpSpPr>
-      <p:sp>
-        <p:nvSpPr>
-          <p:cNvPr id="2" name="TextBox 1"/>
-          <p:cNvSpPr txBox="1"/>
-          <p:nvPr/>
-        </p:nvSpPr>
-        <p:spPr>
-          <a:xfrm>
-            <a:off x="384048" y="219456"/>
-            <a:ext cx="11423599" cy="457200"/>
-          </a:xfrm>
-          <a:prstGeom prst="rect">
-            <a:avLst/>
-          </a:prstGeom>
-          <a:noFill/>
-        </p:spPr>
-        <p:txBody>
-          <a:bodyPr wrap="none">
-            <a:spAutoFit/>
-          </a:bodyPr>
-          <a:lstStyle/>
-          <a:p>
-            <a:r>
-              <a:rPr sz="2000" b="1" i="0" baseline="0">
-                <a:latin typeface="Calibri"/>
-              </a:rPr>
               <a:t>PD20 takeaways</a:t>
             </a:r>
           </a:p>
@@ -6270,6 +6189,2002 @@
           </a:p>
         </p:txBody>
       </p:sp>
+    </p:spTree>
+  </p:cSld>
+  <p:clrMapOvr>
+    <a:masterClrMapping/>
+  </p:clrMapOvr>
+</p:sld>
+</file>
+
+<file path=ppt/slides/slide5.xml><?xml version="1.0" encoding="utf-8"?>
+<p:sld xmlns:a="http://schemas.openxmlformats.org/drawingml/2006/main" xmlns:r="http://schemas.openxmlformats.org/officeDocument/2006/relationships" xmlns:p="http://schemas.openxmlformats.org/presentationml/2006/main">
+  <p:cSld>
+    <p:spTree>
+      <p:nvGrpSpPr>
+        <p:cNvPr id="1" name=""/>
+        <p:cNvGrpSpPr/>
+        <p:nvPr/>
+      </p:nvGrpSpPr>
+      <p:grpSpPr>
+        <a:xfrm>
+          <a:off x="0" y="0"/>
+          <a:ext cx="0" cy="0"/>
+          <a:chOff x="0" y="0"/>
+          <a:chExt cx="0" cy="0"/>
+        </a:xfrm>
+      </p:grpSpPr>
+      <p:pic>
+        <p:nvPicPr>
+          <p:cNvPr id="4" name="Picture 3"/>
+          <p:cNvPicPr>
+            <a:picLocks noChangeAspect="1"/>
+          </p:cNvPicPr>
+          <p:nvPr/>
+        </p:nvPicPr>
+        <p:blipFill>
+          <a:blip r:embed="rId2"/>
+          <a:srcRect/>
+          <a:stretch/>
+        </p:blipFill>
+        <p:spPr>
+          <a:xfrm>
+            <a:off x="3718560" y="974009"/>
+            <a:ext cx="8337713" cy="5417323"/>
+          </a:xfrm>
+          <a:prstGeom prst="rect">
+            <a:avLst/>
+          </a:prstGeom>
+        </p:spPr>
+      </p:pic>
+      <mc:AlternateContent xmlns:mc="http://schemas.openxmlformats.org/markup-compatibility/2006">
+        <mc:Choice xmlns:a14="http://schemas.microsoft.com/office/drawing/2010/main" Requires="a14">
+          <p:sp>
+            <p:nvSpPr>
+              <p:cNvPr id="2" name="TextBox 1"/>
+              <p:cNvSpPr txBox="1"/>
+              <p:nvPr/>
+            </p:nvSpPr>
+            <p:spPr>
+              <a:xfrm>
+                <a:off x="384048" y="219456"/>
+                <a:ext cx="6819944" cy="400110"/>
+              </a:xfrm>
+              <a:prstGeom prst="rect">
+                <a:avLst/>
+              </a:prstGeom>
+              <a:noFill/>
+            </p:spPr>
+            <p:txBody>
+              <a:bodyPr wrap="none">
+                <a:spAutoFit/>
+              </a:bodyPr>
+              <a:lstStyle/>
+              <a:p>
+                <a:r>
+                  <a:rPr sz="2000" b="1" i="0" baseline="0" dirty="0">
+                    <a:latin typeface="Calibri"/>
+                  </a:rPr>
+                  <a:t>PD21 — Calibrate homophily </a:t>
+                </a:r>
+                <a14:m>
+                  <m:oMath xmlns:m="http://schemas.openxmlformats.org/officeDocument/2006/math">
+                    <m:r>
+                      <a:rPr lang="en-US" sz="2000" b="1" i="0" baseline="0" dirty="0" smtClean="0">
+                        <a:latin typeface="Cambria Math" panose="02040503050406030204" pitchFamily="18" charset="0"/>
+                      </a:rPr>
+                      <m:t>𝜌</m:t>
+                    </m:r>
+                  </m:oMath>
+                </a14:m>
+                <a:r>
+                  <a:rPr lang="en-US" sz="2000" b="1" i="0" baseline="0" dirty="0">
+                    <a:latin typeface="Calibri"/>
+                  </a:rPr>
+                  <a:t> </a:t>
+                </a:r>
+                <a:r>
+                  <a:rPr sz="2000" b="1" i="0" baseline="0" dirty="0">
+                    <a:latin typeface="Calibri"/>
+                  </a:rPr>
+                  <a:t>to empirical sorting index </a:t>
+                </a:r>
+                <a14:m>
+                  <m:oMath xmlns:m="http://schemas.openxmlformats.org/officeDocument/2006/math">
+                    <m:sSub>
+                      <m:sSubPr>
+                        <m:ctrlPr>
+                          <a:rPr lang="en-US" sz="2000" b="1" i="0" baseline="0" dirty="0" smtClean="0">
+                            <a:latin typeface="Cambria Math" panose="02040503050406030204" pitchFamily="18" charset="0"/>
+                          </a:rPr>
+                        </m:ctrlPr>
+                      </m:sSubPr>
+                      <m:e>
+                        <m:r>
+                          <a:rPr lang="en-US" sz="2000" b="1" i="0" baseline="0" dirty="0" smtClean="0">
+                            <a:latin typeface="Cambria Math" panose="02040503050406030204" pitchFamily="18" charset="0"/>
+                          </a:rPr>
+                          <m:t>𝐻</m:t>
+                        </m:r>
+                      </m:e>
+                      <m:sub>
+                        <m:r>
+                          <m:rPr>
+                            <m:sty m:val="p"/>
+                          </m:rPr>
+                          <a:rPr lang="en-US" sz="2000" b="1" i="0" baseline="0" dirty="0" smtClean="0">
+                            <a:latin typeface="Cambria Math" panose="02040503050406030204" pitchFamily="18" charset="0"/>
+                          </a:rPr>
+                          <m:t>sort</m:t>
+                        </m:r>
+                      </m:sub>
+                    </m:sSub>
+                  </m:oMath>
+                </a14:m>
+                <a:endParaRPr sz="2000" b="1" i="0" baseline="0" dirty="0">
+                  <a:latin typeface="Calibri"/>
+                </a:endParaRPr>
+              </a:p>
+            </p:txBody>
+          </p:sp>
+        </mc:Choice>
+        <mc:Fallback>
+          <p:sp>
+            <p:nvSpPr>
+              <p:cNvPr id="2" name="TextBox 1"/>
+              <p:cNvSpPr txBox="1">
+                <a:spLocks noRot="1" noChangeAspect="1" noMove="1" noResize="1" noEditPoints="1" noAdjustHandles="1" noChangeArrowheads="1" noChangeShapeType="1" noTextEdit="1"/>
+              </p:cNvSpPr>
+              <p:nvPr/>
+            </p:nvSpPr>
+            <p:spPr>
+              <a:xfrm>
+                <a:off x="384048" y="219456"/>
+                <a:ext cx="6819944" cy="400110"/>
+              </a:xfrm>
+              <a:prstGeom prst="rect">
+                <a:avLst/>
+              </a:prstGeom>
+              <a:blipFill>
+                <a:blip r:embed="rId3"/>
+                <a:stretch>
+                  <a:fillRect l="-929" t="-9375" b="-28125"/>
+                </a:stretch>
+              </a:blipFill>
+            </p:spPr>
+            <p:txBody>
+              <a:bodyPr/>
+              <a:lstStyle/>
+              <a:p>
+                <a:r>
+                  <a:rPr lang="en-US">
+                    <a:noFill/>
+                  </a:rPr>
+                  <a:t> </a:t>
+                </a:r>
+              </a:p>
+            </p:txBody>
+          </p:sp>
+        </mc:Fallback>
+      </mc:AlternateContent>
+      <mc:AlternateContent xmlns:mc="http://schemas.openxmlformats.org/markup-compatibility/2006">
+        <mc:Choice xmlns:a14="http://schemas.microsoft.com/office/drawing/2010/main" Requires="a14">
+          <p:sp>
+            <p:nvSpPr>
+              <p:cNvPr id="3" name="TextBox 2"/>
+              <p:cNvSpPr txBox="1"/>
+              <p:nvPr/>
+            </p:nvSpPr>
+            <p:spPr>
+              <a:xfrm>
+                <a:off x="384048" y="647192"/>
+                <a:ext cx="7094186" cy="260777"/>
+              </a:xfrm>
+              <a:prstGeom prst="rect">
+                <a:avLst/>
+              </a:prstGeom>
+              <a:noFill/>
+            </p:spPr>
+            <p:txBody>
+              <a:bodyPr wrap="none">
+                <a:spAutoFit/>
+              </a:bodyPr>
+              <a:lstStyle/>
+              <a:p>
+                <a:r>
+                  <a:rPr sz="1000" b="0" i="0" baseline="0" dirty="0">
+                    <a:latin typeface="Calibri"/>
+                  </a:rPr>
+                  <a:t>PD21 · LG ASSIGN calibration · 2011-2021 · 50 seeds · bracket </a:t>
+                </a:r>
+                <a:r>
+                  <a:rPr sz="1000" b="0" i="0" baseline="0" dirty="0" err="1">
+                    <a:latin typeface="Calibri"/>
+                  </a:rPr>
+                  <a:t>tol</a:t>
+                </a:r>
+                <a:r>
+                  <a:rPr lang="en-US" sz="1000" b="0" i="0" baseline="0" dirty="0">
+                    <a:latin typeface="Calibri"/>
+                  </a:rPr>
+                  <a:t> </a:t>
+                </a:r>
+                <a14:m>
+                  <m:oMath xmlns:m="http://schemas.openxmlformats.org/officeDocument/2006/math">
+                    <m:r>
+                      <a:rPr lang="en-US" sz="1000" b="0" i="0" baseline="0" dirty="0" smtClean="0">
+                        <a:latin typeface="Cambria Math" panose="02040503050406030204" pitchFamily="18" charset="0"/>
+                      </a:rPr>
+                      <m:t>=0.001</m:t>
+                    </m:r>
+                  </m:oMath>
+                </a14:m>
+                <a:r>
+                  <a:rPr sz="1000" b="0" i="0" baseline="0" dirty="0">
+                    <a:latin typeface="Calibri"/>
+                  </a:rPr>
+                  <a:t> · longitudinal </a:t>
+                </a:r>
+                <a14:m>
+                  <m:oMath xmlns:m="http://schemas.openxmlformats.org/officeDocument/2006/math">
+                    <m:sSup>
+                      <m:sSupPr>
+                        <m:ctrlPr>
+                          <a:rPr lang="en-US" sz="1000" b="0" i="0" baseline="0" dirty="0">
+                            <a:latin typeface="Cambria Math" panose="02040503050406030204" pitchFamily="18" charset="0"/>
+                          </a:rPr>
+                        </m:ctrlPr>
+                      </m:sSupPr>
+                      <m:e>
+                        <m:r>
+                          <a:rPr lang="en-US" sz="1000" b="0" i="0" baseline="0" dirty="0">
+                            <a:latin typeface="Cambria Math" panose="02040503050406030204" pitchFamily="18" charset="0"/>
+                          </a:rPr>
+                          <m:t>𝜌</m:t>
+                        </m:r>
+                      </m:e>
+                      <m:sup>
+                        <m:r>
+                          <a:rPr lang="en-US" sz="1000" b="0" i="0" baseline="0" dirty="0">
+                            <a:latin typeface="Cambria Math" panose="02040503050406030204" pitchFamily="18" charset="0"/>
+                          </a:rPr>
+                          <m:t>∗</m:t>
+                        </m:r>
+                      </m:sup>
+                    </m:sSup>
+                    <m:r>
+                      <a:rPr lang="en-US" sz="1000" b="0" i="0" baseline="0" dirty="0">
+                        <a:latin typeface="Cambria Math" panose="02040503050406030204" pitchFamily="18" charset="0"/>
+                      </a:rPr>
+                      <m:t>≈0.0703</m:t>
+                    </m:r>
+                  </m:oMath>
+                </a14:m>
+                <a:r>
+                  <a:rPr lang="en-US" sz="1000" b="0" i="0" baseline="0" dirty="0">
+                    <a:latin typeface="Calibri"/>
+                  </a:rPr>
+                  <a:t>, </a:t>
+                </a:r>
+                <a14:m>
+                  <m:oMath xmlns:m="http://schemas.openxmlformats.org/officeDocument/2006/math">
+                    <m:sSubSup>
+                      <m:sSubSupPr>
+                        <m:ctrlPr>
+                          <a:rPr lang="en-US" sz="1000" b="0" i="0" baseline="0" dirty="0" smtClean="0">
+                            <a:latin typeface="Cambria Math" panose="02040503050406030204" pitchFamily="18" charset="0"/>
+                          </a:rPr>
+                        </m:ctrlPr>
+                      </m:sSubSupPr>
+                      <m:e>
+                        <m:acc>
+                          <m:accPr>
+                            <m:chr m:val="̅"/>
+                            <m:ctrlPr>
+                              <a:rPr lang="en-US" sz="1000" b="0" i="0" baseline="0" dirty="0" smtClean="0">
+                                <a:latin typeface="Cambria Math" panose="02040503050406030204" pitchFamily="18" charset="0"/>
+                              </a:rPr>
+                            </m:ctrlPr>
+                          </m:accPr>
+                          <m:e>
+                            <m:r>
+                              <a:rPr lang="en-US" sz="1000" b="0" i="0" baseline="0" dirty="0" smtClean="0">
+                                <a:latin typeface="Cambria Math" panose="02040503050406030204" pitchFamily="18" charset="0"/>
+                              </a:rPr>
+                              <m:t>𝐻</m:t>
+                            </m:r>
+                          </m:e>
+                        </m:acc>
+                      </m:e>
+                      <m:sub>
+                        <m:r>
+                          <a:rPr lang="en-US" sz="1000" b="0" i="0" baseline="0" dirty="0" smtClean="0">
+                            <a:latin typeface="Cambria Math" panose="02040503050406030204" pitchFamily="18" charset="0"/>
+                          </a:rPr>
+                          <m:t>𝑠𝑜𝑟𝑡</m:t>
+                        </m:r>
+                      </m:sub>
+                      <m:sup>
+                        <m:r>
+                          <a:rPr lang="en-US" sz="1000" b="0" i="0" baseline="0" dirty="0" smtClean="0">
+                            <a:latin typeface="Cambria Math" panose="02040503050406030204" pitchFamily="18" charset="0"/>
+                          </a:rPr>
+                          <m:t>𝑠𝑖𝑚</m:t>
+                        </m:r>
+                      </m:sup>
+                    </m:sSubSup>
+                    <m:r>
+                      <a:rPr lang="en-US" sz="1000" b="0" i="0" baseline="0" dirty="0" smtClean="0">
+                        <a:latin typeface="Cambria Math" panose="02040503050406030204" pitchFamily="18" charset="0"/>
+                      </a:rPr>
+                      <m:t>=0.118</m:t>
+                    </m:r>
+                  </m:oMath>
+                </a14:m>
+                <a:r>
+                  <a:rPr lang="en-US" sz="1000" b="0" i="0" baseline="0" dirty="0">
+                    <a:latin typeface="Calibri"/>
+                  </a:rPr>
+                  <a:t> , </a:t>
+                </a:r>
+                <a14:m>
+                  <m:oMath xmlns:m="http://schemas.openxmlformats.org/officeDocument/2006/math">
+                    <m:sSubSup>
+                      <m:sSubSupPr>
+                        <m:ctrlPr>
+                          <a:rPr lang="en-US" sz="1000" b="0" i="0" baseline="0" dirty="0" smtClean="0">
+                            <a:latin typeface="Cambria Math" panose="02040503050406030204" pitchFamily="18" charset="0"/>
+                          </a:rPr>
+                        </m:ctrlPr>
+                      </m:sSubSupPr>
+                      <m:e>
+                        <m:acc>
+                          <m:accPr>
+                            <m:chr m:val="̅"/>
+                            <m:ctrlPr>
+                              <a:rPr lang="en-US" sz="1000" b="0" i="0" baseline="0" dirty="0" smtClean="0">
+                                <a:latin typeface="Cambria Math" panose="02040503050406030204" pitchFamily="18" charset="0"/>
+                              </a:rPr>
+                            </m:ctrlPr>
+                          </m:accPr>
+                          <m:e>
+                            <m:r>
+                              <a:rPr lang="en-US" sz="1000" b="0" i="0" baseline="0" dirty="0" smtClean="0">
+                                <a:latin typeface="Cambria Math" panose="02040503050406030204" pitchFamily="18" charset="0"/>
+                              </a:rPr>
+                              <m:t>𝐻</m:t>
+                            </m:r>
+                          </m:e>
+                        </m:acc>
+                      </m:e>
+                      <m:sub>
+                        <m:r>
+                          <a:rPr lang="en-US" sz="1000" b="0" i="0" baseline="0" dirty="0" smtClean="0">
+                            <a:latin typeface="Cambria Math" panose="02040503050406030204" pitchFamily="18" charset="0"/>
+                          </a:rPr>
+                          <m:t>𝑠𝑜𝑟𝑡</m:t>
+                        </m:r>
+                      </m:sub>
+                      <m:sup>
+                        <m:r>
+                          <a:rPr lang="en-US" sz="1000" b="0" i="0" baseline="0" dirty="0" smtClean="0">
+                            <a:latin typeface="Cambria Math" panose="02040503050406030204" pitchFamily="18" charset="0"/>
+                          </a:rPr>
+                          <m:t>𝑒𝑚𝑝</m:t>
+                        </m:r>
+                      </m:sup>
+                    </m:sSubSup>
+                    <m:r>
+                      <a:rPr lang="en-US" sz="1000" b="0" i="0" baseline="0" dirty="0" smtClean="0">
+                        <a:latin typeface="Cambria Math" panose="02040503050406030204" pitchFamily="18" charset="0"/>
+                      </a:rPr>
+                      <m:t>=0.105</m:t>
+                    </m:r>
+                  </m:oMath>
+                </a14:m>
+                <a:endParaRPr sz="1000" b="0" i="0" baseline="0" dirty="0">
+                  <a:latin typeface="Calibri"/>
+                </a:endParaRPr>
+              </a:p>
+            </p:txBody>
+          </p:sp>
+        </mc:Choice>
+        <mc:Fallback>
+          <p:sp>
+            <p:nvSpPr>
+              <p:cNvPr id="3" name="TextBox 2"/>
+              <p:cNvSpPr txBox="1">
+                <a:spLocks noRot="1" noChangeAspect="1" noMove="1" noResize="1" noEditPoints="1" noAdjustHandles="1" noChangeArrowheads="1" noChangeShapeType="1" noTextEdit="1"/>
+              </p:cNvSpPr>
+              <p:nvPr/>
+            </p:nvSpPr>
+            <p:spPr>
+              <a:xfrm>
+                <a:off x="384048" y="647192"/>
+                <a:ext cx="7094186" cy="260777"/>
+              </a:xfrm>
+              <a:prstGeom prst="rect">
+                <a:avLst/>
+              </a:prstGeom>
+              <a:blipFill>
+                <a:blip r:embed="rId4"/>
+                <a:stretch>
+                  <a:fillRect b="-9091"/>
+                </a:stretch>
+              </a:blipFill>
+            </p:spPr>
+            <p:txBody>
+              <a:bodyPr/>
+              <a:lstStyle/>
+              <a:p>
+                <a:r>
+                  <a:rPr lang="en-US">
+                    <a:noFill/>
+                  </a:rPr>
+                  <a:t> </a:t>
+                </a:r>
+              </a:p>
+            </p:txBody>
+          </p:sp>
+        </mc:Fallback>
+      </mc:AlternateContent>
+      <mc:AlternateContent xmlns:mc="http://schemas.openxmlformats.org/markup-compatibility/2006">
+        <mc:Choice xmlns:a14="http://schemas.microsoft.com/office/drawing/2010/main" Requires="a14">
+          <p:sp>
+            <p:nvSpPr>
+              <p:cNvPr id="5" name="TextBox 4"/>
+              <p:cNvSpPr txBox="1"/>
+              <p:nvPr/>
+            </p:nvSpPr>
+            <p:spPr>
+              <a:xfrm>
+                <a:off x="182880" y="1053120"/>
+                <a:ext cx="3535680" cy="5296470"/>
+              </a:xfrm>
+              <a:prstGeom prst="rect">
+                <a:avLst/>
+              </a:prstGeom>
+              <a:noFill/>
+            </p:spPr>
+            <p:txBody>
+              <a:bodyPr wrap="square" numCol="1">
+                <a:noAutofit/>
+              </a:bodyPr>
+              <a:lstStyle/>
+              <a:p>
+                <a:pPr>
+                  <a:lnSpc>
+                    <a:spcPct val="150000"/>
+                  </a:lnSpc>
+                  <a:buChar char="•"/>
+                </a:pPr>
+                <a:r>
+                  <a:rPr sz="1000" b="0" i="0" baseline="0" dirty="0">
+                    <a:latin typeface="Calibri"/>
+                  </a:rPr>
+                  <a:t>  </a:t>
+                </a:r>
+                <a:r>
+                  <a:rPr lang="en-US" sz="1000" b="0" i="0" baseline="0" dirty="0">
+                    <a:latin typeface="Calibri"/>
+                  </a:rPr>
+                  <a:t>C</a:t>
+                </a:r>
+                <a:r>
+                  <a:rPr sz="1000" b="0" i="0" baseline="0" dirty="0">
+                    <a:latin typeface="Calibri"/>
+                  </a:rPr>
+                  <a:t>alibrate ASSIGN </a:t>
+                </a:r>
+                <a14:m>
+                  <m:oMath xmlns:m="http://schemas.openxmlformats.org/officeDocument/2006/math">
+                    <m:r>
+                      <a:rPr lang="en-US" sz="1000" b="0" i="0" baseline="0" dirty="0" smtClean="0">
+                        <a:latin typeface="Cambria Math" panose="02040503050406030204" pitchFamily="18" charset="0"/>
+                      </a:rPr>
+                      <m:t>𝜌</m:t>
+                    </m:r>
+                  </m:oMath>
+                </a14:m>
+                <a:r>
+                  <a:rPr sz="1000" b="0" i="0" baseline="0" dirty="0">
+                    <a:latin typeface="Calibri"/>
+                  </a:rPr>
+                  <a:t> so LG simulated </a:t>
+                </a:r>
+                <a14:m>
+                  <m:oMath xmlns:m="http://schemas.openxmlformats.org/officeDocument/2006/math">
+                    <m:sSub>
+                      <m:sSubPr>
+                        <m:ctrlPr>
+                          <a:rPr lang="en-US" sz="1000" b="0" i="0" baseline="0" dirty="0">
+                            <a:latin typeface="Cambria Math" panose="02040503050406030204" pitchFamily="18" charset="0"/>
+                          </a:rPr>
+                        </m:ctrlPr>
+                      </m:sSubPr>
+                      <m:e>
+                        <m:r>
+                          <a:rPr lang="en-US" sz="1000" b="0" i="0" baseline="0" dirty="0">
+                            <a:latin typeface="Cambria Math" panose="02040503050406030204" pitchFamily="18" charset="0"/>
+                          </a:rPr>
+                          <m:t>𝐻</m:t>
+                        </m:r>
+                      </m:e>
+                      <m:sub>
+                        <m:r>
+                          <m:rPr>
+                            <m:sty m:val="p"/>
+                          </m:rPr>
+                          <a:rPr lang="en-US" sz="1000" b="0" i="0" baseline="0" dirty="0">
+                            <a:latin typeface="Cambria Math" panose="02040503050406030204" pitchFamily="18" charset="0"/>
+                          </a:rPr>
+                          <m:t>sort</m:t>
+                        </m:r>
+                      </m:sub>
+                    </m:sSub>
+                  </m:oMath>
+                </a14:m>
+                <a:r>
+                  <a:rPr sz="1000" b="0" i="0" baseline="0" dirty="0">
+                    <a:latin typeface="Calibri"/>
+                  </a:rPr>
+                  <a:t> matches empirical NCAA; formal </a:t>
+                </a:r>
+                <a14:m>
+                  <m:oMath xmlns:m="http://schemas.openxmlformats.org/officeDocument/2006/math">
+                    <m:r>
+                      <a:rPr lang="en-US" sz="1000" b="0" i="0" baseline="0" dirty="0" smtClean="0">
+                        <a:latin typeface="Cambria Math" panose="02040503050406030204" pitchFamily="18" charset="0"/>
+                      </a:rPr>
+                      <m:t>𝜌</m:t>
+                    </m:r>
+                  </m:oMath>
+                </a14:m>
+                <a:r>
+                  <a:rPr sz="1000" b="0" i="0" baseline="0" dirty="0">
+                    <a:latin typeface="Calibri"/>
+                  </a:rPr>
+                  <a:t> MLE parked.</a:t>
+                </a:r>
+              </a:p>
+              <a:p>
+                <a:pPr>
+                  <a:lnSpc>
+                    <a:spcPct val="150000"/>
+                  </a:lnSpc>
+                  <a:buChar char="•"/>
+                </a:pPr>
+                <a:r>
+                  <a:rPr sz="1000" b="0" i="0" baseline="0" dirty="0">
+                    <a:latin typeface="Calibri"/>
+                  </a:rPr>
+                  <a:t>  Panel: 2011–2021 hero MBB · min 20 min · empirical roster caps · PPM z within season.</a:t>
+                </a:r>
+              </a:p>
+              <a:p>
+                <a:pPr>
+                  <a:lnSpc>
+                    <a:spcPct val="150000"/>
+                  </a:lnSpc>
+                  <a:buChar char="•"/>
+                </a:pPr>
+                <a:r>
+                  <a:rPr sz="1000" b="0" i="0" baseline="0" dirty="0">
+                    <a:latin typeface="Calibri"/>
+                  </a:rPr>
+                  <a:t>  Search: bracket + bisect (</a:t>
+                </a:r>
+                <a:r>
+                  <a:rPr sz="1000" b="0" i="0" baseline="0" dirty="0" err="1">
+                    <a:latin typeface="Calibri"/>
+                  </a:rPr>
+                  <a:t>tol</a:t>
+                </a:r>
+                <a14:m>
+                  <m:oMath xmlns:m="http://schemas.openxmlformats.org/officeDocument/2006/math">
+                    <m:r>
+                      <a:rPr lang="en-US" sz="1000" b="0" i="0" baseline="0" dirty="0" smtClean="0">
+                        <a:latin typeface="Cambria Math" panose="02040503050406030204" pitchFamily="18" charset="0"/>
+                      </a:rPr>
+                      <m:t>=0.001</m:t>
+                    </m:r>
+                  </m:oMath>
+                </a14:m>
+                <a:r>
+                  <a:rPr sz="1000" b="0" i="0" baseline="0" dirty="0">
+                    <a:latin typeface="Calibri"/>
+                  </a:rPr>
+                  <a:t>), </a:t>
+                </a:r>
+                <a14:m>
+                  <m:oMath xmlns:m="http://schemas.openxmlformats.org/officeDocument/2006/math">
+                    <m:r>
+                      <a:rPr lang="en-US" sz="1000" b="0" i="0" baseline="0" dirty="0" smtClean="0">
+                        <a:latin typeface="Cambria Math" panose="02040503050406030204" pitchFamily="18" charset="0"/>
+                      </a:rPr>
+                      <m:t>50</m:t>
+                    </m:r>
+                  </m:oMath>
+                </a14:m>
+                <a:r>
+                  <a:rPr sz="1000" b="0" i="0" baseline="0" dirty="0">
+                    <a:latin typeface="Calibri"/>
+                  </a:rPr>
+                  <a:t> seeds/arm; </a:t>
+                </a:r>
+                <a14:m>
+                  <m:oMath xmlns:m="http://schemas.openxmlformats.org/officeDocument/2006/math">
+                    <m:sSubSup>
+                      <m:sSubSupPr>
+                        <m:ctrlPr>
+                          <a:rPr lang="en-US" sz="1000" b="0" i="0" baseline="0" dirty="0">
+                            <a:latin typeface="Cambria Math" panose="02040503050406030204" pitchFamily="18" charset="0"/>
+                          </a:rPr>
+                        </m:ctrlPr>
+                      </m:sSubSupPr>
+                      <m:e>
+                        <m:r>
+                          <a:rPr lang="en-US" sz="1000" b="0" i="0" baseline="0" dirty="0">
+                            <a:latin typeface="Cambria Math" panose="02040503050406030204" pitchFamily="18" charset="0"/>
+                          </a:rPr>
+                          <m:t>𝐻</m:t>
+                        </m:r>
+                      </m:e>
+                      <m:sub>
+                        <m:r>
+                          <m:rPr>
+                            <m:sty m:val="p"/>
+                          </m:rPr>
+                          <a:rPr lang="en-US" sz="1000" b="0" i="0" baseline="0" dirty="0">
+                            <a:latin typeface="Cambria Math" panose="02040503050406030204" pitchFamily="18" charset="0"/>
+                          </a:rPr>
+                          <m:t>sort</m:t>
+                        </m:r>
+                      </m:sub>
+                      <m:sup>
+                        <m:r>
+                          <m:rPr>
+                            <m:sty m:val="p"/>
+                          </m:rPr>
+                          <a:rPr lang="en-US" sz="1000" b="0" i="0" baseline="0" dirty="0">
+                            <a:latin typeface="Cambria Math" panose="02040503050406030204" pitchFamily="18" charset="0"/>
+                          </a:rPr>
+                          <m:t>sim</m:t>
+                        </m:r>
+                      </m:sup>
+                    </m:sSubSup>
+                  </m:oMath>
+                </a14:m>
+                <a:r>
+                  <a:rPr sz="1000" b="0" i="0" baseline="0" dirty="0">
+                    <a:latin typeface="Calibri"/>
+                  </a:rPr>
+                  <a:t> monotone in </a:t>
+                </a:r>
+                <a14:m>
+                  <m:oMath xmlns:m="http://schemas.openxmlformats.org/officeDocument/2006/math">
+                    <m:r>
+                      <a:rPr lang="en-US" sz="1000" b="0" i="0" baseline="0" dirty="0" smtClean="0">
+                        <a:latin typeface="Cambria Math" panose="02040503050406030204" pitchFamily="18" charset="0"/>
+                      </a:rPr>
+                      <m:t>𝜌</m:t>
+                    </m:r>
+                  </m:oMath>
+                </a14:m>
+                <a:r>
+                  <a:rPr sz="1000" b="0" i="0" baseline="0" dirty="0">
+                    <a:latin typeface="Calibri"/>
+                  </a:rPr>
+                  <a:t>.</a:t>
+                </a:r>
+              </a:p>
+              <a:p>
+                <a:pPr>
+                  <a:lnSpc>
+                    <a:spcPct val="150000"/>
+                  </a:lnSpc>
+                  <a:buChar char="•"/>
+                </a:pPr>
+                <a:r>
+                  <a:rPr sz="1000" b="0" i="0" baseline="0" dirty="0">
+                    <a:latin typeface="Calibri"/>
+                  </a:rPr>
+                  <a:t>  </a:t>
+                </a:r>
+                <a14:m>
+                  <m:oMath xmlns:m="http://schemas.openxmlformats.org/officeDocument/2006/math">
+                    <m:sSub>
+                      <m:sSubPr>
+                        <m:ctrlPr>
+                          <a:rPr lang="en-US" sz="1000" b="0" i="0" baseline="0" dirty="0">
+                            <a:latin typeface="Cambria Math" panose="02040503050406030204" pitchFamily="18" charset="0"/>
+                          </a:rPr>
+                        </m:ctrlPr>
+                      </m:sSubPr>
+                      <m:e>
+                        <m:r>
+                          <a:rPr lang="en-US" sz="1000" b="0" i="0" baseline="0" dirty="0">
+                            <a:latin typeface="Cambria Math" panose="02040503050406030204" pitchFamily="18" charset="0"/>
+                          </a:rPr>
+                          <m:t>𝐻</m:t>
+                        </m:r>
+                      </m:e>
+                      <m:sub>
+                        <m:r>
+                          <a:rPr lang="en-US" sz="1000" b="0" i="0" baseline="0" dirty="0">
+                            <a:latin typeface="Cambria Math" panose="02040503050406030204" pitchFamily="18" charset="0"/>
+                          </a:rPr>
+                          <m:t>𝑠𝑜𝑟𝑡</m:t>
+                        </m:r>
+                      </m:sub>
+                    </m:sSub>
+                    <m:r>
+                      <a:rPr lang="en-US" sz="1000" b="0" i="0" baseline="0" dirty="0">
+                        <a:latin typeface="Cambria Math" panose="02040503050406030204" pitchFamily="18" charset="0"/>
+                      </a:rPr>
+                      <m:t>=1−</m:t>
+                    </m:r>
+                    <m:nary>
+                      <m:naryPr>
+                        <m:chr m:val="∑"/>
+                        <m:limLoc m:val="undOvr"/>
+                        <m:supHide m:val="on"/>
+                        <m:ctrlPr>
+                          <a:rPr lang="en-US" sz="1000" b="0" i="0" baseline="0" dirty="0">
+                            <a:latin typeface="Cambria Math" panose="02040503050406030204" pitchFamily="18" charset="0"/>
+                          </a:rPr>
+                        </m:ctrlPr>
+                      </m:naryPr>
+                      <m:sub>
+                        <m:r>
+                          <a:rPr lang="en-US" sz="1000" b="0" i="0" baseline="0" dirty="0">
+                            <a:latin typeface="Cambria Math" panose="02040503050406030204" pitchFamily="18" charset="0"/>
+                          </a:rPr>
+                          <m:t>𝑖</m:t>
+                        </m:r>
+                      </m:sub>
+                      <m:sup/>
+                      <m:e>
+                        <m:sSup>
+                          <m:sSupPr>
+                            <m:ctrlPr>
+                              <a:rPr lang="en-US" sz="1000" b="0" i="0" baseline="0" dirty="0">
+                                <a:latin typeface="Cambria Math" panose="02040503050406030204" pitchFamily="18" charset="0"/>
+                              </a:rPr>
+                            </m:ctrlPr>
+                          </m:sSupPr>
+                          <m:e>
+                            <m:d>
+                              <m:dPr>
+                                <m:ctrlPr>
+                                  <a:rPr lang="en-US" sz="1000" b="0" i="0" baseline="0" dirty="0">
+                                    <a:latin typeface="Cambria Math" panose="02040503050406030204" pitchFamily="18" charset="0"/>
+                                  </a:rPr>
+                                </m:ctrlPr>
+                              </m:dPr>
+                              <m:e>
+                                <m:sSub>
+                                  <m:sSubPr>
+                                    <m:ctrlPr>
+                                      <a:rPr lang="en-US" sz="1000" b="0" i="0" baseline="0" dirty="0">
+                                        <a:latin typeface="Cambria Math" panose="02040503050406030204" pitchFamily="18" charset="0"/>
+                                      </a:rPr>
+                                    </m:ctrlPr>
+                                  </m:sSubPr>
+                                  <m:e>
+                                    <m:acc>
+                                      <m:accPr>
+                                        <m:chr m:val="ˆ"/>
+                                        <m:ctrlPr>
+                                          <a:rPr lang="en-US" sz="1000" b="0" i="0" baseline="0" dirty="0">
+                                            <a:latin typeface="Cambria Math" panose="02040503050406030204" pitchFamily="18" charset="0"/>
+                                          </a:rPr>
+                                        </m:ctrlPr>
+                                      </m:accPr>
+                                      <m:e>
+                                        <m:r>
+                                          <a:rPr lang="en-US" sz="1000" b="0" i="0" baseline="0" dirty="0">
+                                            <a:latin typeface="Cambria Math" panose="02040503050406030204" pitchFamily="18" charset="0"/>
+                                          </a:rPr>
+                                          <m:t>𝐴</m:t>
+                                        </m:r>
+                                      </m:e>
+                                    </m:acc>
+                                  </m:e>
+                                  <m:sub>
+                                    <m:r>
+                                      <a:rPr lang="en-US" sz="1000" b="0" i="0" baseline="0" dirty="0">
+                                        <a:latin typeface="Cambria Math" panose="02040503050406030204" pitchFamily="18" charset="0"/>
+                                      </a:rPr>
+                                      <m:t>𝑖</m:t>
+                                    </m:r>
+                                  </m:sub>
+                                </m:sSub>
+                                <m:r>
+                                  <a:rPr lang="en-US" sz="1000" b="0" i="0" baseline="0" dirty="0">
+                                    <a:latin typeface="Cambria Math" panose="02040503050406030204" pitchFamily="18" charset="0"/>
+                                  </a:rPr>
+                                  <m:t>−</m:t>
+                                </m:r>
+                                <m:sSub>
+                                  <m:sSubPr>
+                                    <m:ctrlPr>
+                                      <a:rPr lang="en-US" sz="1000" b="0" i="0" baseline="0" dirty="0">
+                                        <a:latin typeface="Cambria Math" panose="02040503050406030204" pitchFamily="18" charset="0"/>
+                                      </a:rPr>
+                                    </m:ctrlPr>
+                                  </m:sSubPr>
+                                  <m:e>
+                                    <m:acc>
+                                      <m:accPr>
+                                        <m:chr m:val="ˆ"/>
+                                        <m:ctrlPr>
+                                          <a:rPr lang="en-US" sz="1000" b="0" i="0" baseline="0" dirty="0">
+                                            <a:latin typeface="Cambria Math" panose="02040503050406030204" pitchFamily="18" charset="0"/>
+                                          </a:rPr>
+                                        </m:ctrlPr>
+                                      </m:accPr>
+                                      <m:e>
+                                        <m:r>
+                                          <a:rPr lang="en-US" sz="1000" b="0" i="0" baseline="0" dirty="0">
+                                            <a:latin typeface="Cambria Math" panose="02040503050406030204" pitchFamily="18" charset="0"/>
+                                          </a:rPr>
+                                          <m:t>𝜇</m:t>
+                                        </m:r>
+                                      </m:e>
+                                    </m:acc>
+                                  </m:e>
+                                  <m:sub>
+                                    <m:r>
+                                      <a:rPr lang="en-US" sz="1000" b="0" i="0" baseline="0" dirty="0">
+                                        <a:latin typeface="Cambria Math" panose="02040503050406030204" pitchFamily="18" charset="0"/>
+                                      </a:rPr>
+                                      <m:t>𝑔</m:t>
+                                    </m:r>
+                                    <m:d>
+                                      <m:dPr>
+                                        <m:ctrlPr>
+                                          <a:rPr lang="en-US" sz="1000" b="0" i="0" baseline="0" dirty="0">
+                                            <a:latin typeface="Cambria Math" panose="02040503050406030204" pitchFamily="18" charset="0"/>
+                                          </a:rPr>
+                                        </m:ctrlPr>
+                                      </m:dPr>
+                                      <m:e>
+                                        <m:r>
+                                          <a:rPr lang="en-US" sz="1000" b="0" i="0" baseline="0" dirty="0">
+                                            <a:latin typeface="Cambria Math" panose="02040503050406030204" pitchFamily="18" charset="0"/>
+                                          </a:rPr>
+                                          <m:t>𝑖</m:t>
+                                        </m:r>
+                                      </m:e>
+                                    </m:d>
+                                  </m:sub>
+                                </m:sSub>
+                              </m:e>
+                            </m:d>
+                          </m:e>
+                          <m:sup>
+                            <m:r>
+                              <a:rPr lang="en-US" sz="1000" b="0" i="0" baseline="0" dirty="0">
+                                <a:latin typeface="Cambria Math" panose="02040503050406030204" pitchFamily="18" charset="0"/>
+                              </a:rPr>
+                              <m:t>2</m:t>
+                            </m:r>
+                          </m:sup>
+                        </m:sSup>
+                      </m:e>
+                    </m:nary>
+                    <m:r>
+                      <a:rPr lang="en-US" sz="1000" b="0" i="0" baseline="0" dirty="0">
+                        <a:latin typeface="Cambria Math" panose="02040503050406030204" pitchFamily="18" charset="0"/>
+                      </a:rPr>
+                      <m:t>/</m:t>
+                    </m:r>
+                    <m:nary>
+                      <m:naryPr>
+                        <m:chr m:val="∑"/>
+                        <m:limLoc m:val="undOvr"/>
+                        <m:supHide m:val="on"/>
+                        <m:ctrlPr>
+                          <a:rPr lang="en-US" sz="1000" b="0" i="0" baseline="0" dirty="0">
+                            <a:latin typeface="Cambria Math" panose="02040503050406030204" pitchFamily="18" charset="0"/>
+                          </a:rPr>
+                        </m:ctrlPr>
+                      </m:naryPr>
+                      <m:sub>
+                        <m:r>
+                          <a:rPr lang="en-US" sz="1000" b="0" i="0" baseline="0" dirty="0">
+                            <a:latin typeface="Cambria Math" panose="02040503050406030204" pitchFamily="18" charset="0"/>
+                          </a:rPr>
+                          <m:t>𝑖</m:t>
+                        </m:r>
+                      </m:sub>
+                      <m:sup/>
+                      <m:e>
+                        <m:sSup>
+                          <m:sSupPr>
+                            <m:ctrlPr>
+                              <a:rPr lang="en-US" sz="1000" b="0" i="0" baseline="0" dirty="0">
+                                <a:latin typeface="Cambria Math" panose="02040503050406030204" pitchFamily="18" charset="0"/>
+                              </a:rPr>
+                            </m:ctrlPr>
+                          </m:sSupPr>
+                          <m:e>
+                            <m:d>
+                              <m:dPr>
+                                <m:ctrlPr>
+                                  <a:rPr lang="en-US" sz="1000" b="0" i="0" baseline="0" dirty="0">
+                                    <a:latin typeface="Cambria Math" panose="02040503050406030204" pitchFamily="18" charset="0"/>
+                                  </a:rPr>
+                                </m:ctrlPr>
+                              </m:dPr>
+                              <m:e>
+                                <m:sSub>
+                                  <m:sSubPr>
+                                    <m:ctrlPr>
+                                      <a:rPr lang="en-US" sz="1000" b="0" i="0" baseline="0" dirty="0">
+                                        <a:latin typeface="Cambria Math" panose="02040503050406030204" pitchFamily="18" charset="0"/>
+                                      </a:rPr>
+                                    </m:ctrlPr>
+                                  </m:sSubPr>
+                                  <m:e>
+                                    <m:acc>
+                                      <m:accPr>
+                                        <m:chr m:val="ˆ"/>
+                                        <m:ctrlPr>
+                                          <a:rPr lang="en-US" sz="1000" b="0" i="0" baseline="0" dirty="0">
+                                            <a:latin typeface="Cambria Math" panose="02040503050406030204" pitchFamily="18" charset="0"/>
+                                          </a:rPr>
+                                        </m:ctrlPr>
+                                      </m:accPr>
+                                      <m:e>
+                                        <m:r>
+                                          <a:rPr lang="en-US" sz="1000" b="0" i="0" baseline="0" dirty="0">
+                                            <a:latin typeface="Cambria Math" panose="02040503050406030204" pitchFamily="18" charset="0"/>
+                                          </a:rPr>
+                                          <m:t>𝐴</m:t>
+                                        </m:r>
+                                      </m:e>
+                                    </m:acc>
+                                  </m:e>
+                                  <m:sub>
+                                    <m:r>
+                                      <a:rPr lang="en-US" sz="1000" b="0" i="0" baseline="0" dirty="0">
+                                        <a:latin typeface="Cambria Math" panose="02040503050406030204" pitchFamily="18" charset="0"/>
+                                      </a:rPr>
+                                      <m:t>𝑖</m:t>
+                                    </m:r>
+                                  </m:sub>
+                                </m:sSub>
+                                <m:r>
+                                  <a:rPr lang="en-US" sz="1000" b="0" i="0" baseline="0" dirty="0">
+                                    <a:latin typeface="Cambria Math" panose="02040503050406030204" pitchFamily="18" charset="0"/>
+                                  </a:rPr>
+                                  <m:t>−</m:t>
+                                </m:r>
+                                <m:acc>
+                                  <m:accPr>
+                                    <m:chr m:val="̅"/>
+                                    <m:ctrlPr>
+                                      <a:rPr lang="en-US" sz="1000" b="0" i="0" baseline="0" dirty="0">
+                                        <a:latin typeface="Cambria Math" panose="02040503050406030204" pitchFamily="18" charset="0"/>
+                                      </a:rPr>
+                                    </m:ctrlPr>
+                                  </m:accPr>
+                                  <m:e>
+                                    <m:r>
+                                      <a:rPr lang="en-US" sz="1000" b="0" i="0" baseline="0" dirty="0">
+                                        <a:latin typeface="Cambria Math" panose="02040503050406030204" pitchFamily="18" charset="0"/>
+                                      </a:rPr>
+                                      <m:t>𝐴</m:t>
+                                    </m:r>
+                                  </m:e>
+                                </m:acc>
+                              </m:e>
+                            </m:d>
+                          </m:e>
+                          <m:sup>
+                            <m:r>
+                              <a:rPr lang="en-US" sz="1000" b="0" i="0" baseline="0" dirty="0">
+                                <a:latin typeface="Cambria Math" panose="02040503050406030204" pitchFamily="18" charset="0"/>
+                              </a:rPr>
+                              <m:t>2</m:t>
+                            </m:r>
+                          </m:sup>
+                        </m:sSup>
+                      </m:e>
+                    </m:nary>
+                  </m:oMath>
+                </a14:m>
+                <a:r>
+                  <a:rPr sz="1000" b="0" i="0" baseline="0" dirty="0">
+                    <a:latin typeface="Calibri"/>
+                  </a:rPr>
+                  <a:t> — realized sorting on a fixed partition.</a:t>
+                </a:r>
+              </a:p>
+              <a:p>
+                <a:pPr>
+                  <a:lnSpc>
+                    <a:spcPct val="150000"/>
+                  </a:lnSpc>
+                  <a:buChar char="•"/>
+                </a:pPr>
+                <a:r>
+                  <a:rPr sz="1000" b="0" i="0" baseline="0" dirty="0">
+                    <a:latin typeface="Calibri"/>
+                  </a:rPr>
+                  <a:t>  Longitudinal </a:t>
+                </a:r>
+                <a14:m>
+                  <m:oMath xmlns:m="http://schemas.openxmlformats.org/officeDocument/2006/math">
+                    <m:sSup>
+                      <m:sSupPr>
+                        <m:ctrlPr>
+                          <a:rPr lang="en-US" sz="1000" b="0" i="0" baseline="0" dirty="0">
+                            <a:latin typeface="Cambria Math" panose="02040503050406030204" pitchFamily="18" charset="0"/>
+                          </a:rPr>
+                        </m:ctrlPr>
+                      </m:sSupPr>
+                      <m:e>
+                        <m:r>
+                          <a:rPr lang="en-US" sz="1000" b="0" i="0" baseline="0" dirty="0">
+                            <a:latin typeface="Cambria Math" panose="02040503050406030204" pitchFamily="18" charset="0"/>
+                          </a:rPr>
+                          <m:t>𝜌</m:t>
+                        </m:r>
+                      </m:e>
+                      <m:sup>
+                        <m:r>
+                          <a:rPr lang="en-US" sz="1000" b="0" i="0" baseline="0" dirty="0">
+                            <a:latin typeface="Cambria Math" panose="02040503050406030204" pitchFamily="18" charset="0"/>
+                          </a:rPr>
+                          <m:t>∗</m:t>
+                        </m:r>
+                      </m:sup>
+                    </m:sSup>
+                    <m:r>
+                      <a:rPr lang="en-US" sz="1000" b="0" i="0" baseline="0" dirty="0">
+                        <a:latin typeface="Cambria Math" panose="02040503050406030204" pitchFamily="18" charset="0"/>
+                      </a:rPr>
+                      <m:t>≈0.07031</m:t>
+                    </m:r>
+                  </m:oMath>
+                </a14:m>
+                <a:r>
+                  <a:rPr sz="1000" b="0" i="0" baseline="0" dirty="0">
+                    <a:latin typeface="Calibri"/>
+                  </a:rPr>
+                  <a:t>; mean </a:t>
+                </a:r>
+                <a14:m>
+                  <m:oMath xmlns:m="http://schemas.openxmlformats.org/officeDocument/2006/math">
+                    <m:d>
+                      <m:dPr>
+                        <m:begChr m:val="|"/>
+                        <m:endChr m:val="|"/>
+                        <m:ctrlPr>
+                          <a:rPr lang="en-US" sz="1000" b="0" i="0" baseline="0" dirty="0">
+                            <a:latin typeface="Cambria Math" panose="02040503050406030204" pitchFamily="18" charset="0"/>
+                          </a:rPr>
+                        </m:ctrlPr>
+                      </m:dPr>
+                      <m:e>
+                        <m:r>
+                          <a:rPr lang="en-US" sz="1000" b="0" i="0" baseline="0" dirty="0">
+                            <a:latin typeface="Cambria Math" panose="02040503050406030204" pitchFamily="18" charset="0"/>
+                          </a:rPr>
+                          <m:t>𝑒𝑟𝑟𝑜𝑟</m:t>
+                        </m:r>
+                      </m:e>
+                    </m:d>
+                  </m:oMath>
+                </a14:m>
+                <a:r>
+                  <a:rPr sz="1000" b="0" i="0" baseline="0" dirty="0">
+                    <a:latin typeface="Calibri"/>
+                  </a:rPr>
+                  <a:t> at </a:t>
+                </a:r>
+                <a14:m>
+                  <m:oMath xmlns:m="http://schemas.openxmlformats.org/officeDocument/2006/math">
+                    <m:sSup>
+                      <m:sSupPr>
+                        <m:ctrlPr>
+                          <a:rPr lang="en-US" sz="1000" b="0" i="0" baseline="0" dirty="0">
+                            <a:latin typeface="Cambria Math" panose="02040503050406030204" pitchFamily="18" charset="0"/>
+                          </a:rPr>
+                        </m:ctrlPr>
+                      </m:sSupPr>
+                      <m:e>
+                        <m:r>
+                          <a:rPr lang="en-US" sz="1000" b="0" i="0" baseline="0" dirty="0">
+                            <a:latin typeface="Cambria Math" panose="02040503050406030204" pitchFamily="18" charset="0"/>
+                          </a:rPr>
+                          <m:t>𝜌</m:t>
+                        </m:r>
+                      </m:e>
+                      <m:sup>
+                        <m:r>
+                          <a:rPr lang="en-US" sz="1000" b="0" i="0" baseline="0" dirty="0">
+                            <a:latin typeface="Cambria Math" panose="02040503050406030204" pitchFamily="18" charset="0"/>
+                          </a:rPr>
+                          <m:t>∗</m:t>
+                        </m:r>
+                      </m:sup>
+                    </m:sSup>
+                    <m:r>
+                      <a:rPr lang="en-US" sz="1000" b="0" i="0" baseline="0" dirty="0" smtClean="0">
+                        <a:latin typeface="Cambria Math" panose="02040503050406030204" pitchFamily="18" charset="0"/>
+                      </a:rPr>
+                      <m:t>=1.5</m:t>
+                    </m:r>
+                    <m:r>
+                      <a:rPr lang="en-US" sz="1000" b="0" i="0" baseline="0" dirty="0" smtClean="0">
+                        <a:latin typeface="Cambria Math" panose="02040503050406030204" pitchFamily="18" charset="0"/>
+                      </a:rPr>
+                      <m:t>𝑒</m:t>
+                    </m:r>
+                    <m:r>
+                      <a:rPr lang="en-US" sz="1000" b="0" i="0" baseline="0" dirty="0" smtClean="0">
+                        <a:latin typeface="Cambria Math" panose="02040503050406030204" pitchFamily="18" charset="0"/>
+                      </a:rPr>
+                      <m:t>−05</m:t>
+                    </m:r>
+                  </m:oMath>
+                </a14:m>
+                <a:r>
+                  <a:rPr sz="1000" b="0" i="0" baseline="0" dirty="0">
+                    <a:latin typeface="Calibri"/>
+                  </a:rPr>
+                  <a:t>.</a:t>
+                </a:r>
+              </a:p>
+              <a:p>
+                <a:pPr>
+                  <a:lnSpc>
+                    <a:spcPct val="150000"/>
+                  </a:lnSpc>
+                  <a:buChar char="•"/>
+                </a:pPr>
+                <a:r>
+                  <a:rPr sz="1000" b="0" i="0" baseline="0" dirty="0">
+                    <a:latin typeface="Calibri"/>
+                  </a:rPr>
+                  <a:t>  Per-season: 6/11 seasons at </a:t>
+                </a:r>
+                <a14:m>
+                  <m:oMath xmlns:m="http://schemas.openxmlformats.org/officeDocument/2006/math">
+                    <m:sSup>
+                      <m:sSupPr>
+                        <m:ctrlPr>
+                          <a:rPr lang="en-US" sz="1000" b="0" i="0" baseline="0" dirty="0">
+                            <a:latin typeface="Cambria Math" panose="02040503050406030204" pitchFamily="18" charset="0"/>
+                          </a:rPr>
+                        </m:ctrlPr>
+                      </m:sSupPr>
+                      <m:e>
+                        <m:r>
+                          <a:rPr lang="en-US" sz="1000" b="0" i="0" baseline="0" dirty="0">
+                            <a:latin typeface="Cambria Math" panose="02040503050406030204" pitchFamily="18" charset="0"/>
+                          </a:rPr>
+                          <m:t>𝜌</m:t>
+                        </m:r>
+                      </m:e>
+                      <m:sup>
+                        <m:r>
+                          <a:rPr lang="en-US" sz="1000" b="0" i="0" baseline="0" dirty="0">
+                            <a:latin typeface="Cambria Math" panose="02040503050406030204" pitchFamily="18" charset="0"/>
+                          </a:rPr>
+                          <m:t>∗</m:t>
+                        </m:r>
+                      </m:sup>
+                    </m:sSup>
+                    <m:r>
+                      <a:rPr lang="en-US" sz="1000" b="0" i="0" baseline="0" dirty="0">
+                        <a:latin typeface="Cambria Math" panose="02040503050406030204" pitchFamily="18" charset="0"/>
+                      </a:rPr>
+                      <m:t>=0</m:t>
+                    </m:r>
+                  </m:oMath>
+                </a14:m>
+                <a:r>
+                  <a:rPr sz="1000" b="0" i="0" baseline="0" dirty="0">
+                    <a:latin typeface="Calibri"/>
+                  </a:rPr>
+                  <a:t>; </a:t>
+                </a:r>
+                <a:endParaRPr lang="en-US" sz="1000" b="0" i="0" baseline="0" dirty="0">
+                  <a:latin typeface="Calibri"/>
+                </a:endParaRPr>
+              </a:p>
+              <a:p>
+                <a:pPr>
+                  <a:lnSpc>
+                    <a:spcPct val="150000"/>
+                  </a:lnSpc>
+                </a:pPr>
+                <a:r>
+                  <a:rPr lang="en-US" sz="1000" b="0" i="0" baseline="0" dirty="0">
+                    <a:latin typeface="Calibri"/>
+                  </a:rPr>
+                  <a:t>     </a:t>
+                </a:r>
+                <a:r>
+                  <a:rPr sz="1000" b="0" i="0" baseline="0" dirty="0">
+                    <a:latin typeface="Calibri"/>
+                  </a:rPr>
+                  <a:t>nonzero — </a:t>
+                </a:r>
+                <a:endParaRPr lang="en-US" sz="1000" b="0" i="0" baseline="0" dirty="0">
+                  <a:latin typeface="Calibri"/>
+                </a:endParaRPr>
+              </a:p>
+              <a:p>
+                <a:pPr>
+                  <a:lnSpc>
+                    <a:spcPct val="150000"/>
+                  </a:lnSpc>
+                </a:pPr>
+                <a:r>
+                  <a:rPr lang="en-US" sz="1000" b="0" i="0" baseline="0" dirty="0">
+                    <a:latin typeface="Calibri"/>
+                  </a:rPr>
+                  <a:t>     </a:t>
+                </a:r>
+                <a:r>
+                  <a:rPr sz="1000" b="0" i="0" baseline="0" dirty="0">
+                    <a:latin typeface="Calibri"/>
+                  </a:rPr>
+                  <a:t>2013: </a:t>
+                </a:r>
+                <a14:m>
+                  <m:oMath xmlns:m="http://schemas.openxmlformats.org/officeDocument/2006/math">
+                    <m:sSup>
+                      <m:sSupPr>
+                        <m:ctrlPr>
+                          <a:rPr lang="en-US" sz="1000" b="0" i="0" baseline="0" dirty="0">
+                            <a:latin typeface="Cambria Math" panose="02040503050406030204" pitchFamily="18" charset="0"/>
+                          </a:rPr>
+                        </m:ctrlPr>
+                      </m:sSupPr>
+                      <m:e>
+                        <m:r>
+                          <a:rPr lang="en-US" sz="1000" b="0" i="0" baseline="0" dirty="0">
+                            <a:latin typeface="Cambria Math" panose="02040503050406030204" pitchFamily="18" charset="0"/>
+                          </a:rPr>
+                          <m:t>𝜌</m:t>
+                        </m:r>
+                      </m:e>
+                      <m:sup>
+                        <m:r>
+                          <a:rPr lang="en-US" sz="1000" b="0" i="0" baseline="0" dirty="0">
+                            <a:latin typeface="Cambria Math" panose="02040503050406030204" pitchFamily="18" charset="0"/>
+                          </a:rPr>
+                          <m:t>∗</m:t>
+                        </m:r>
+                      </m:sup>
+                    </m:sSup>
+                    <m:r>
+                      <a:rPr lang="en-US" sz="1000" b="0" i="0" baseline="0" dirty="0">
+                        <a:latin typeface="Cambria Math" panose="02040503050406030204" pitchFamily="18" charset="0"/>
+                      </a:rPr>
+                      <m:t>≈0.0715</m:t>
+                    </m:r>
+                  </m:oMath>
+                </a14:m>
+                <a:r>
+                  <a:rPr sz="1000" b="0" i="0" baseline="0" dirty="0">
+                    <a:latin typeface="Calibri"/>
+                  </a:rPr>
+                  <a:t>, </a:t>
+                </a:r>
+                <a:r>
+                  <a:rPr lang="en-US" sz="1000" dirty="0">
+                    <a:latin typeface="Calibri"/>
+                  </a:rPr>
+                  <a:t> </a:t>
+                </a:r>
+                <a:r>
+                  <a:rPr sz="1000" b="0" i="0" baseline="0" dirty="0">
+                    <a:latin typeface="Calibri"/>
+                  </a:rPr>
+                  <a:t>2015: </a:t>
+                </a:r>
+                <a14:m>
+                  <m:oMath xmlns:m="http://schemas.openxmlformats.org/officeDocument/2006/math">
+                    <m:sSup>
+                      <m:sSupPr>
+                        <m:ctrlPr>
+                          <a:rPr lang="en-US" sz="1000" b="0" i="0" baseline="0" dirty="0">
+                            <a:latin typeface="Cambria Math" panose="02040503050406030204" pitchFamily="18" charset="0"/>
+                          </a:rPr>
+                        </m:ctrlPr>
+                      </m:sSupPr>
+                      <m:e>
+                        <m:r>
+                          <a:rPr lang="en-US" sz="1000" b="0" i="0" baseline="0" dirty="0">
+                            <a:latin typeface="Cambria Math" panose="02040503050406030204" pitchFamily="18" charset="0"/>
+                          </a:rPr>
+                          <m:t>𝜌</m:t>
+                        </m:r>
+                      </m:e>
+                      <m:sup>
+                        <m:r>
+                          <a:rPr lang="en-US" sz="1000" b="0" i="0" baseline="0" dirty="0">
+                            <a:latin typeface="Cambria Math" panose="02040503050406030204" pitchFamily="18" charset="0"/>
+                          </a:rPr>
+                          <m:t>∗</m:t>
+                        </m:r>
+                      </m:sup>
+                    </m:sSup>
+                    <m:r>
+                      <a:rPr lang="en-US" sz="1000" b="0" i="0" baseline="0" dirty="0">
+                        <a:latin typeface="Cambria Math" panose="02040503050406030204" pitchFamily="18" charset="0"/>
+                      </a:rPr>
+                      <m:t>≈0.0668</m:t>
+                    </m:r>
+                  </m:oMath>
+                </a14:m>
+                <a:r>
+                  <a:rPr sz="1000" b="0" i="0" baseline="0" dirty="0">
+                    <a:latin typeface="Calibri"/>
+                  </a:rPr>
+                  <a:t>, </a:t>
+                </a:r>
+                <a:r>
+                  <a:rPr lang="en-US" sz="1000" dirty="0">
+                    <a:latin typeface="Calibri"/>
+                  </a:rPr>
+                  <a:t> </a:t>
+                </a:r>
+                <a:r>
+                  <a:rPr sz="1000" b="0" i="0" baseline="0" dirty="0">
+                    <a:latin typeface="Calibri"/>
+                  </a:rPr>
+                  <a:t>2018: </a:t>
+                </a:r>
+                <a14:m>
+                  <m:oMath xmlns:m="http://schemas.openxmlformats.org/officeDocument/2006/math">
+                    <m:sSup>
+                      <m:sSupPr>
+                        <m:ctrlPr>
+                          <a:rPr lang="en-US" sz="1000" b="0" i="0" baseline="0" dirty="0">
+                            <a:latin typeface="Cambria Math" panose="02040503050406030204" pitchFamily="18" charset="0"/>
+                          </a:rPr>
+                        </m:ctrlPr>
+                      </m:sSupPr>
+                      <m:e>
+                        <m:r>
+                          <a:rPr lang="en-US" sz="1000" b="0" i="0" baseline="0" dirty="0">
+                            <a:latin typeface="Cambria Math" panose="02040503050406030204" pitchFamily="18" charset="0"/>
+                          </a:rPr>
+                          <m:t>𝜌</m:t>
+                        </m:r>
+                      </m:e>
+                      <m:sup>
+                        <m:r>
+                          <a:rPr lang="en-US" sz="1000" b="0" i="0" baseline="0" dirty="0">
+                            <a:latin typeface="Cambria Math" panose="02040503050406030204" pitchFamily="18" charset="0"/>
+                          </a:rPr>
+                          <m:t>∗</m:t>
+                        </m:r>
+                      </m:sup>
+                    </m:sSup>
+                    <m:r>
+                      <a:rPr lang="en-US" sz="1000" b="0" i="0" baseline="0" dirty="0">
+                        <a:latin typeface="Cambria Math" panose="02040503050406030204" pitchFamily="18" charset="0"/>
+                      </a:rPr>
+                      <m:t>≈0.0168</m:t>
+                    </m:r>
+                  </m:oMath>
+                </a14:m>
+                <a:r>
+                  <a:rPr sz="1000" b="0" i="0" baseline="0" dirty="0">
+                    <a:latin typeface="Calibri"/>
+                  </a:rPr>
+                  <a:t>, </a:t>
+                </a:r>
+                <a:endParaRPr lang="en-US" sz="1000" b="0" i="0" baseline="0" dirty="0">
+                  <a:latin typeface="Calibri"/>
+                </a:endParaRPr>
+              </a:p>
+              <a:p>
+                <a:pPr>
+                  <a:lnSpc>
+                    <a:spcPct val="150000"/>
+                  </a:lnSpc>
+                </a:pPr>
+                <a:r>
+                  <a:rPr lang="en-US" sz="1000" b="0" i="0" baseline="0" dirty="0">
+                    <a:latin typeface="Calibri"/>
+                  </a:rPr>
+                  <a:t>     </a:t>
+                </a:r>
+                <a:r>
+                  <a:rPr sz="1000" b="0" i="0" baseline="0" dirty="0">
+                    <a:latin typeface="Calibri"/>
+                  </a:rPr>
+                  <a:t>2019: </a:t>
+                </a:r>
+                <a14:m>
+                  <m:oMath xmlns:m="http://schemas.openxmlformats.org/officeDocument/2006/math">
+                    <m:sSup>
+                      <m:sSupPr>
+                        <m:ctrlPr>
+                          <a:rPr lang="en-US" sz="1000" b="0" i="0" baseline="0" dirty="0">
+                            <a:latin typeface="Cambria Math" panose="02040503050406030204" pitchFamily="18" charset="0"/>
+                          </a:rPr>
+                        </m:ctrlPr>
+                      </m:sSupPr>
+                      <m:e>
+                        <m:r>
+                          <a:rPr lang="en-US" sz="1000" b="0" i="0" baseline="0" dirty="0">
+                            <a:latin typeface="Cambria Math" panose="02040503050406030204" pitchFamily="18" charset="0"/>
+                          </a:rPr>
+                          <m:t>𝜌</m:t>
+                        </m:r>
+                      </m:e>
+                      <m:sup>
+                        <m:r>
+                          <a:rPr lang="en-US" sz="1000" b="0" i="0" baseline="0" dirty="0">
+                            <a:latin typeface="Cambria Math" panose="02040503050406030204" pitchFamily="18" charset="0"/>
+                          </a:rPr>
+                          <m:t>∗</m:t>
+                        </m:r>
+                      </m:sup>
+                    </m:sSup>
+                    <m:r>
+                      <a:rPr lang="en-US" sz="1000" b="0" i="0" baseline="0" dirty="0">
+                        <a:latin typeface="Cambria Math" panose="02040503050406030204" pitchFamily="18" charset="0"/>
+                      </a:rPr>
+                      <m:t>≈0.0293</m:t>
+                    </m:r>
+                  </m:oMath>
+                </a14:m>
+                <a:r>
+                  <a:rPr sz="1000" b="0" i="0" baseline="0" dirty="0">
+                    <a:latin typeface="Calibri"/>
+                  </a:rPr>
+                  <a:t>, </a:t>
+                </a:r>
+                <a:r>
+                  <a:rPr lang="en-US" sz="1000" b="0" i="0" baseline="0" dirty="0">
+                    <a:latin typeface="Calibri"/>
+                  </a:rPr>
+                  <a:t> </a:t>
+                </a:r>
+                <a:r>
+                  <a:rPr sz="1000" b="0" i="0" baseline="0" dirty="0">
+                    <a:latin typeface="Calibri"/>
+                  </a:rPr>
+                  <a:t>2021: </a:t>
+                </a:r>
+                <a14:m>
+                  <m:oMath xmlns:m="http://schemas.openxmlformats.org/officeDocument/2006/math">
+                    <m:sSup>
+                      <m:sSupPr>
+                        <m:ctrlPr>
+                          <a:rPr lang="en-US" sz="1000" b="0" i="0" baseline="0" dirty="0">
+                            <a:latin typeface="Cambria Math" panose="02040503050406030204" pitchFamily="18" charset="0"/>
+                          </a:rPr>
+                        </m:ctrlPr>
+                      </m:sSupPr>
+                      <m:e>
+                        <m:r>
+                          <a:rPr lang="en-US" sz="1000" b="0" i="0" baseline="0" dirty="0">
+                            <a:latin typeface="Cambria Math" panose="02040503050406030204" pitchFamily="18" charset="0"/>
+                          </a:rPr>
+                          <m:t>𝜌</m:t>
+                        </m:r>
+                      </m:e>
+                      <m:sup>
+                        <m:r>
+                          <a:rPr lang="en-US" sz="1000" b="0" i="0" baseline="0" dirty="0">
+                            <a:latin typeface="Cambria Math" panose="02040503050406030204" pitchFamily="18" charset="0"/>
+                          </a:rPr>
+                          <m:t>∗</m:t>
+                        </m:r>
+                      </m:sup>
+                    </m:sSup>
+                    <m:r>
+                      <a:rPr lang="en-US" sz="1000" b="0" i="0" baseline="0" dirty="0">
+                        <a:latin typeface="Cambria Math" panose="02040503050406030204" pitchFamily="18" charset="0"/>
+                      </a:rPr>
+                      <m:t>≈0.0652</m:t>
+                    </m:r>
+                  </m:oMath>
+                </a14:m>
+                <a:endParaRPr sz="1000" b="0" i="0" baseline="0" dirty="0">
+                  <a:latin typeface="Calibri"/>
+                </a:endParaRPr>
+              </a:p>
+              <a:p>
+                <a:pPr>
+                  <a:lnSpc>
+                    <a:spcPct val="150000"/>
+                  </a:lnSpc>
+                  <a:buChar char="•"/>
+                </a:pPr>
+                <a:r>
+                  <a:rPr sz="1000" b="0" i="0" baseline="0" dirty="0">
+                    <a:latin typeface="Calibri"/>
+                  </a:rPr>
+                  <a:t>  Legacy reference </a:t>
+                </a:r>
+                <a:endParaRPr lang="en-US" sz="1000" b="0" i="0" baseline="0" dirty="0">
+                  <a:latin typeface="Cambria Math" panose="02040503050406030204" pitchFamily="18" charset="0"/>
+                </a:endParaRPr>
+              </a:p>
+              <a:p>
+                <a:pPr>
+                  <a:lnSpc>
+                    <a:spcPct val="150000"/>
+                  </a:lnSpc>
+                </a:pPr>
+                <a:r>
+                  <a:rPr lang="en-US" sz="1000" b="0" baseline="0" dirty="0"/>
+                  <a:t>    </a:t>
+                </a:r>
+                <a14:m>
+                  <m:oMath xmlns:m="http://schemas.openxmlformats.org/officeDocument/2006/math">
+                    <m:r>
+                      <a:rPr lang="en-US" sz="1000" b="0" i="0" baseline="0" dirty="0" smtClean="0">
+                        <a:latin typeface="Cambria Math" panose="02040503050406030204" pitchFamily="18" charset="0"/>
+                      </a:rPr>
+                      <m:t>𝜌</m:t>
+                    </m:r>
+                    <m:r>
+                      <a:rPr lang="en-US" sz="1000" b="0" i="0" baseline="0" dirty="0" smtClean="0">
+                        <a:latin typeface="Cambria Math" panose="02040503050406030204" pitchFamily="18" charset="0"/>
+                      </a:rPr>
+                      <m:t>=0.5</m:t>
+                    </m:r>
+                  </m:oMath>
+                </a14:m>
+                <a:r>
+                  <a:rPr sz="1000" b="0" i="0" baseline="0" dirty="0">
+                    <a:latin typeface="Calibri"/>
+                  </a:rPr>
+                  <a:t>: mean </a:t>
+                </a:r>
+                <a14:m>
+                  <m:oMath xmlns:m="http://schemas.openxmlformats.org/officeDocument/2006/math">
+                    <m:d>
+                      <m:dPr>
+                        <m:begChr m:val="|"/>
+                        <m:endChr m:val="|"/>
+                        <m:ctrlPr>
+                          <a:rPr lang="en-US" sz="1000" b="0" i="0" baseline="0" dirty="0">
+                            <a:latin typeface="Cambria Math" panose="02040503050406030204" pitchFamily="18" charset="0"/>
+                          </a:rPr>
+                        </m:ctrlPr>
+                      </m:dPr>
+                      <m:e>
+                        <m:r>
+                          <a:rPr lang="en-US" sz="1000" b="0" i="0" baseline="0" dirty="0">
+                            <a:latin typeface="Cambria Math" panose="02040503050406030204" pitchFamily="18" charset="0"/>
+                          </a:rPr>
+                          <m:t>𝑒𝑟𝑟𝑜𝑟</m:t>
+                        </m:r>
+                      </m:e>
+                    </m:d>
+                    <m:r>
+                      <a:rPr lang="en-US" sz="1000" b="0" i="0" baseline="0" dirty="0">
+                        <a:latin typeface="Cambria Math" panose="02040503050406030204" pitchFamily="18" charset="0"/>
+                      </a:rPr>
+                      <m:t>≈0.098</m:t>
+                    </m:r>
+                  </m:oMath>
+                </a14:m>
+                <a:r>
+                  <a:rPr sz="1000" b="0" i="0" baseline="0" dirty="0">
+                    <a:latin typeface="Calibri"/>
+                  </a:rPr>
+                  <a:t> vs </a:t>
+                </a:r>
+                <a14:m>
+                  <m:oMath xmlns:m="http://schemas.openxmlformats.org/officeDocument/2006/math">
+                    <m:r>
+                      <a:rPr lang="en-US" sz="1000" b="0" i="0" baseline="0" dirty="0" smtClean="0">
+                        <a:latin typeface="Cambria Math" panose="02040503050406030204" pitchFamily="18" charset="0"/>
+                      </a:rPr>
+                      <m:t>≈1.5</m:t>
+                    </m:r>
+                    <m:r>
+                      <a:rPr lang="en-US" sz="1000" b="0" i="0" baseline="0" dirty="0" smtClean="0">
+                        <a:latin typeface="Cambria Math" panose="02040503050406030204" pitchFamily="18" charset="0"/>
+                      </a:rPr>
+                      <m:t>𝑒</m:t>
+                    </m:r>
+                    <m:r>
+                      <a:rPr lang="en-US" sz="1000" b="0" i="0" baseline="0" dirty="0" smtClean="0">
+                        <a:latin typeface="Cambria Math" panose="02040503050406030204" pitchFamily="18" charset="0"/>
+                      </a:rPr>
+                      <m:t>−05</m:t>
+                    </m:r>
+                  </m:oMath>
+                </a14:m>
+                <a:r>
+                  <a:rPr sz="1000" b="0" i="0" baseline="0" dirty="0">
+                    <a:latin typeface="Calibri"/>
+                  </a:rPr>
+                  <a:t> at </a:t>
+                </a:r>
+                <a14:m>
+                  <m:oMath xmlns:m="http://schemas.openxmlformats.org/officeDocument/2006/math">
+                    <m:sSup>
+                      <m:sSupPr>
+                        <m:ctrlPr>
+                          <a:rPr lang="en-US" sz="1000" b="0" i="0" baseline="0" dirty="0">
+                            <a:latin typeface="Cambria Math" panose="02040503050406030204" pitchFamily="18" charset="0"/>
+                          </a:rPr>
+                        </m:ctrlPr>
+                      </m:sSupPr>
+                      <m:e>
+                        <m:r>
+                          <a:rPr lang="en-US" sz="1000" b="0" i="0" baseline="0" dirty="0">
+                            <a:latin typeface="Cambria Math" panose="02040503050406030204" pitchFamily="18" charset="0"/>
+                          </a:rPr>
+                          <m:t>𝜌</m:t>
+                        </m:r>
+                      </m:e>
+                      <m:sup>
+                        <m:r>
+                          <a:rPr lang="en-US" sz="1000" b="0" i="0" baseline="0" dirty="0">
+                            <a:latin typeface="Cambria Math" panose="02040503050406030204" pitchFamily="18" charset="0"/>
+                          </a:rPr>
+                          <m:t>∗</m:t>
+                        </m:r>
+                      </m:sup>
+                    </m:sSup>
+                  </m:oMath>
+                </a14:m>
+                <a:r>
+                  <a:rPr sz="1000" b="0" i="0" baseline="0" dirty="0">
+                    <a:latin typeface="Calibri"/>
+                  </a:rPr>
+                  <a:t>.</a:t>
+                </a:r>
+              </a:p>
+              <a:p>
+                <a:pPr>
+                  <a:lnSpc>
+                    <a:spcPct val="150000"/>
+                  </a:lnSpc>
+                  <a:buChar char="•"/>
+                </a:pPr>
+                <a:r>
+                  <a:rPr sz="1000" b="0" i="0" baseline="0" dirty="0">
+                    <a:latin typeface="Calibri"/>
+                  </a:rPr>
+                  <a:t>  VECTOR lock: </a:t>
+                </a:r>
+                <a14:m>
+                  <m:oMath xmlns:m="http://schemas.openxmlformats.org/officeDocument/2006/math">
+                    <m:sSub>
+                      <m:sSubPr>
+                        <m:ctrlPr>
+                          <a:rPr lang="en-US" sz="1000" b="0" i="0" baseline="0" dirty="0">
+                            <a:latin typeface="Cambria Math" panose="02040503050406030204" pitchFamily="18" charset="0"/>
+                          </a:rPr>
+                        </m:ctrlPr>
+                      </m:sSubPr>
+                      <m:e>
+                        <m:r>
+                          <a:rPr lang="en-US" sz="1000" b="0" i="0" baseline="0" dirty="0">
+                            <a:latin typeface="Cambria Math" panose="02040503050406030204" pitchFamily="18" charset="0"/>
+                          </a:rPr>
+                          <m:t>𝐻</m:t>
+                        </m:r>
+                      </m:e>
+                      <m:sub>
+                        <m:r>
+                          <a:rPr lang="en-US" sz="1000" b="0" i="0" baseline="0" dirty="0">
+                            <a:latin typeface="Cambria Math" panose="02040503050406030204" pitchFamily="18" charset="0"/>
+                          </a:rPr>
+                          <m:t>𝑠𝑜𝑟𝑡</m:t>
+                        </m:r>
+                      </m:sub>
+                    </m:sSub>
+                  </m:oMath>
+                </a14:m>
+                <a:r>
+                  <a:rPr sz="1000" b="0" i="0" baseline="0" dirty="0">
+                    <a:latin typeface="Calibri"/>
+                  </a:rPr>
+                  <a:t> is realized sorting — not the generative homophily knob </a:t>
+                </a:r>
+                <a14:m>
+                  <m:oMath xmlns:m="http://schemas.openxmlformats.org/officeDocument/2006/math">
+                    <m:r>
+                      <a:rPr lang="en-US" sz="1000" b="0" i="0" baseline="0" dirty="0" smtClean="0">
+                        <a:latin typeface="Cambria Math" panose="02040503050406030204" pitchFamily="18" charset="0"/>
+                      </a:rPr>
+                      <m:t>𝜌</m:t>
+                    </m:r>
+                  </m:oMath>
+                </a14:m>
+                <a:r>
+                  <a:rPr sz="1000" b="0" i="0" baseline="0" dirty="0">
+                    <a:latin typeface="Calibri"/>
+                  </a:rPr>
+                  <a:t>.</a:t>
+                </a:r>
+              </a:p>
+              <a:p>
+                <a:pPr>
+                  <a:lnSpc>
+                    <a:spcPct val="150000"/>
+                  </a:lnSpc>
+                  <a:buChar char="•"/>
+                </a:pPr>
+                <a:r>
+                  <a:rPr sz="1000" b="0" i="0" baseline="0" dirty="0">
+                    <a:latin typeface="Calibri"/>
+                  </a:rPr>
+                  <a:t>  Figure: small multiples — blue sim curve, red empirical line, green </a:t>
+                </a:r>
+                <a14:m>
+                  <m:oMath xmlns:m="http://schemas.openxmlformats.org/officeDocument/2006/math">
+                    <m:sSup>
+                      <m:sSupPr>
+                        <m:ctrlPr>
+                          <a:rPr lang="en-US" sz="1000" b="0" i="0" baseline="0" dirty="0">
+                            <a:latin typeface="Cambria Math" panose="02040503050406030204" pitchFamily="18" charset="0"/>
+                          </a:rPr>
+                        </m:ctrlPr>
+                      </m:sSupPr>
+                      <m:e>
+                        <m:r>
+                          <a:rPr lang="en-US" sz="1000" b="0" i="0" baseline="0" dirty="0">
+                            <a:latin typeface="Cambria Math" panose="02040503050406030204" pitchFamily="18" charset="0"/>
+                          </a:rPr>
+                          <m:t>𝜌</m:t>
+                        </m:r>
+                      </m:e>
+                      <m:sup>
+                        <m:r>
+                          <a:rPr lang="en-US" sz="1000" b="0" i="0" baseline="0" dirty="0">
+                            <a:latin typeface="Cambria Math" panose="02040503050406030204" pitchFamily="18" charset="0"/>
+                          </a:rPr>
+                          <m:t>∗</m:t>
+                        </m:r>
+                      </m:sup>
+                    </m:sSup>
+                  </m:oMath>
+                </a14:m>
+                <a:r>
+                  <a:rPr sz="1000" b="0" i="0" baseline="0" dirty="0">
+                    <a:latin typeface="Calibri"/>
+                  </a:rPr>
+                  <a:t> (x-axis zoomed to evaluated bracket; reference </a:t>
+                </a:r>
+                <a14:m>
+                  <m:oMath xmlns:m="http://schemas.openxmlformats.org/officeDocument/2006/math">
+                    <m:r>
+                      <a:rPr lang="en-US" sz="1000" b="0" i="0" baseline="0" dirty="0" smtClean="0">
+                        <a:latin typeface="Cambria Math" panose="02040503050406030204" pitchFamily="18" charset="0"/>
+                      </a:rPr>
+                      <m:t>𝜌</m:t>
+                    </m:r>
+                  </m:oMath>
+                </a14:m>
+                <a:r>
+                  <a:rPr sz="1000" b="0" i="0" baseline="0" dirty="0">
+                    <a:latin typeface="Calibri"/>
+                  </a:rPr>
+                  <a:t> excluded from axis).</a:t>
+                </a:r>
+              </a:p>
+            </p:txBody>
+          </p:sp>
+        </mc:Choice>
+        <mc:Fallback>
+          <p:sp>
+            <p:nvSpPr>
+              <p:cNvPr id="5" name="TextBox 4"/>
+              <p:cNvSpPr txBox="1">
+                <a:spLocks noRot="1" noChangeAspect="1" noMove="1" noResize="1" noEditPoints="1" noAdjustHandles="1" noChangeArrowheads="1" noChangeShapeType="1" noTextEdit="1"/>
+              </p:cNvSpPr>
+              <p:nvPr/>
+            </p:nvSpPr>
+            <p:spPr>
+              <a:xfrm>
+                <a:off x="182880" y="1053120"/>
+                <a:ext cx="3535680" cy="5296470"/>
+              </a:xfrm>
+              <a:prstGeom prst="rect">
+                <a:avLst/>
+              </a:prstGeom>
+              <a:blipFill>
+                <a:blip r:embed="rId5"/>
+                <a:stretch>
+                  <a:fillRect/>
+                </a:stretch>
+              </a:blipFill>
+            </p:spPr>
+            <p:txBody>
+              <a:bodyPr/>
+              <a:lstStyle/>
+              <a:p>
+                <a:r>
+                  <a:rPr lang="en-US">
+                    <a:noFill/>
+                  </a:rPr>
+                  <a:t> </a:t>
+                </a:r>
+              </a:p>
+            </p:txBody>
+          </p:sp>
+        </mc:Fallback>
+      </mc:AlternateContent>
+      <mc:AlternateContent xmlns:mc="http://schemas.openxmlformats.org/markup-compatibility/2006">
+        <mc:Choice xmlns:a14="http://schemas.microsoft.com/office/drawing/2010/main" Requires="a14">
+          <p:sp>
+            <p:nvSpPr>
+              <p:cNvPr id="6" name="TextBox 5"/>
+              <p:cNvSpPr txBox="1"/>
+              <p:nvPr/>
+            </p:nvSpPr>
+            <p:spPr>
+              <a:xfrm>
+                <a:off x="384046" y="6349589"/>
+                <a:ext cx="11423599" cy="261610"/>
+              </a:xfrm>
+              <a:prstGeom prst="rect">
+                <a:avLst/>
+              </a:prstGeom>
+              <a:noFill/>
+            </p:spPr>
+            <p:txBody>
+              <a:bodyPr wrap="square">
+                <a:spAutoFit/>
+              </a:bodyPr>
+              <a:lstStyle/>
+              <a:p>
+                <a:pPr algn="l"/>
+                <a:r>
+                  <a:rPr sz="1100" b="1" i="0" baseline="0" dirty="0">
+                    <a:latin typeface="Calibri"/>
+                  </a:rPr>
+                  <a:t>Claim (Alex): Near-zero ASSIGN homophily </a:t>
+                </a:r>
+                <a14:m>
+                  <m:oMath xmlns:m="http://schemas.openxmlformats.org/officeDocument/2006/math">
+                    <m:r>
+                      <a:rPr lang="en-US" sz="1100" b="1" i="0" baseline="0" dirty="0" smtClean="0">
+                        <a:latin typeface="Cambria Math" panose="02040503050406030204" pitchFamily="18" charset="0"/>
+                      </a:rPr>
+                      <m:t>𝜌</m:t>
+                    </m:r>
+                  </m:oMath>
+                </a14:m>
+                <a:r>
+                  <a:rPr sz="1100" b="1" i="0" baseline="0" dirty="0">
+                    <a:latin typeface="Calibri"/>
+                  </a:rPr>
+                  <a:t> matches empirical </a:t>
+                </a:r>
+                <a14:m>
+                  <m:oMath xmlns:m="http://schemas.openxmlformats.org/officeDocument/2006/math">
+                    <m:sSub>
+                      <m:sSubPr>
+                        <m:ctrlPr>
+                          <a:rPr lang="en-US" sz="1100" b="1" i="0" baseline="0" dirty="0">
+                            <a:latin typeface="Cambria Math" panose="02040503050406030204" pitchFamily="18" charset="0"/>
+                          </a:rPr>
+                        </m:ctrlPr>
+                      </m:sSubPr>
+                      <m:e>
+                        <m:r>
+                          <a:rPr lang="en-US" sz="1100" b="1" i="0" baseline="0" dirty="0">
+                            <a:latin typeface="Cambria Math" panose="02040503050406030204" pitchFamily="18" charset="0"/>
+                          </a:rPr>
+                          <m:t>𝐻</m:t>
+                        </m:r>
+                      </m:e>
+                      <m:sub>
+                        <m:r>
+                          <m:rPr>
+                            <m:sty m:val="p"/>
+                          </m:rPr>
+                          <a:rPr lang="en-US" sz="1100" b="1" i="0" baseline="0" dirty="0">
+                            <a:latin typeface="Cambria Math" panose="02040503050406030204" pitchFamily="18" charset="0"/>
+                          </a:rPr>
+                          <m:t>sort</m:t>
+                        </m:r>
+                      </m:sub>
+                    </m:sSub>
+                  </m:oMath>
+                </a14:m>
+                <a:r>
+                  <a:rPr sz="1100" b="1" i="0" baseline="0" dirty="0">
+                    <a:latin typeface="Calibri"/>
+                  </a:rPr>
+                  <a:t> on the hero panel — legacy </a:t>
+                </a:r>
+                <a14:m>
+                  <m:oMath xmlns:m="http://schemas.openxmlformats.org/officeDocument/2006/math">
+                    <m:r>
+                      <a:rPr lang="en-US" sz="1100" b="1" i="0" baseline="0" dirty="0" smtClean="0">
+                        <a:latin typeface="Cambria Math" panose="02040503050406030204" pitchFamily="18" charset="0"/>
+                      </a:rPr>
+                      <m:t>𝜌</m:t>
+                    </m:r>
+                    <m:r>
+                      <a:rPr lang="en-US" sz="1100" b="1" i="0" baseline="0" dirty="0" smtClean="0">
+                        <a:latin typeface="Cambria Math" panose="02040503050406030204" pitchFamily="18" charset="0"/>
+                      </a:rPr>
+                      <m:t>=0.5</m:t>
+                    </m:r>
+                  </m:oMath>
+                </a14:m>
+                <a:r>
+                  <a:rPr sz="1100" b="1" i="0" baseline="0" dirty="0">
+                    <a:latin typeface="Calibri"/>
+                  </a:rPr>
+                  <a:t> overshoots simulated sorting by </a:t>
+                </a:r>
+                <a14:m>
+                  <m:oMath xmlns:m="http://schemas.openxmlformats.org/officeDocument/2006/math">
+                    <m:r>
+                      <a:rPr lang="en-US" sz="1100" b="1" i="0" baseline="0" dirty="0" smtClean="0">
+                        <a:latin typeface="Cambria Math" panose="02040503050406030204" pitchFamily="18" charset="0"/>
+                      </a:rPr>
+                      <m:t>∼0.10</m:t>
+                    </m:r>
+                  </m:oMath>
+                </a14:m>
+                <a:r>
+                  <a:rPr sz="1100" b="1" i="0" baseline="0" dirty="0">
+                    <a:latin typeface="Calibri"/>
+                  </a:rPr>
+                  <a:t>.</a:t>
+                </a:r>
+              </a:p>
+            </p:txBody>
+          </p:sp>
+        </mc:Choice>
+        <mc:Fallback>
+          <p:sp>
+            <p:nvSpPr>
+              <p:cNvPr id="6" name="TextBox 5"/>
+              <p:cNvSpPr txBox="1">
+                <a:spLocks noRot="1" noChangeAspect="1" noMove="1" noResize="1" noEditPoints="1" noAdjustHandles="1" noChangeArrowheads="1" noChangeShapeType="1" noTextEdit="1"/>
+              </p:cNvSpPr>
+              <p:nvPr/>
+            </p:nvSpPr>
+            <p:spPr>
+              <a:xfrm>
+                <a:off x="384046" y="6349589"/>
+                <a:ext cx="11423599" cy="261610"/>
+              </a:xfrm>
+              <a:prstGeom prst="rect">
+                <a:avLst/>
+              </a:prstGeom>
+              <a:blipFill>
+                <a:blip r:embed="rId6"/>
+                <a:stretch>
+                  <a:fillRect b="-14286"/>
+                </a:stretch>
+              </a:blipFill>
+            </p:spPr>
+            <p:txBody>
+              <a:bodyPr/>
+              <a:lstStyle/>
+              <a:p>
+                <a:r>
+                  <a:rPr lang="en-US">
+                    <a:noFill/>
+                  </a:rPr>
+                  <a:t> </a:t>
+                </a:r>
+              </a:p>
+            </p:txBody>
+          </p:sp>
+        </mc:Fallback>
+      </mc:AlternateContent>
     </p:spTree>
   </p:cSld>
   <p:clrMapOvr>

</xml_diff>